<commit_message>
docs: Make presentation 100% dark theme and embed high-res relational ER diagram
</commit_message>
<xml_diff>
--- a/Library_Lending_System_Presentation.pptx
+++ b/Library_Lending_System_Presentation.pptx
@@ -3090,6 +3090,14 @@
 <file path=ppt/slides/slide1.xml><?xml version="1.0" encoding="utf-8"?>
 <p:sld xmlns:a="http://schemas.openxmlformats.org/drawingml/2006/main" xmlns:p="http://schemas.openxmlformats.org/presentationml/2006/main" xmlns:r="http://schemas.openxmlformats.org/officeDocument/2006/relationships">
   <p:cSld>
+    <p:bg>
+      <p:bgPr>
+        <a:solidFill>
+          <a:srgbClr val="09090B"/>
+        </a:solidFill>
+        <a:effectLst/>
+      </p:bgPr>
+    </p:bg>
     <p:spTree>
       <p:nvGrpSpPr>
         <p:cNvPr id="1" name=""/>
@@ -3105,49 +3113,6 @@
         </p:nvSpPr>
         <p:spPr>
           <a:xfrm>
-            <a:off x="0" y="0"/>
-            <a:ext cx="12191695" cy="6858000"/>
-          </a:xfrm>
-          <a:prstGeom prst="rect">
-            <a:avLst/>
-          </a:prstGeom>
-          <a:solidFill>
-            <a:srgbClr val="0A0A0B"/>
-          </a:solidFill>
-          <a:ln>
-            <a:noFill/>
-          </a:ln>
-        </p:spPr>
-        <p:style>
-          <a:lnRef idx="1">
-            <a:schemeClr val="accent1"/>
-          </a:lnRef>
-          <a:fillRef idx="3">
-            <a:schemeClr val="accent1"/>
-          </a:fillRef>
-          <a:effectRef idx="2">
-            <a:schemeClr val="accent1"/>
-          </a:effectRef>
-          <a:fontRef idx="minor">
-            <a:schemeClr val="lt1"/>
-          </a:fontRef>
-        </p:style>
-        <p:txBody>
-          <a:bodyPr rtlCol="0" anchor="ctr"/>
-          <a:lstStyle/>
-          <a:p>
-            <a:pPr algn="ctr"/>
-          </a:p>
-        </p:txBody>
-      </p:sp>
-      <p:sp>
-        <p:nvSpPr>
-          <p:cNvPr id="3" name="Rectangle 2"/>
-          <p:cNvSpPr/>
-          <p:nvPr/>
-        </p:nvSpPr>
-        <p:spPr>
-          <a:xfrm>
             <a:off x="914400" y="914400"/>
             <a:ext cx="1371600" cy="73152"/>
           </a:xfrm>
@@ -3185,7 +3150,7 @@
       </p:sp>
       <p:sp>
         <p:nvSpPr>
-          <p:cNvPr id="4" name="TextBox 3"/>
+          <p:cNvPr id="3" name="TextBox 2"/>
           <p:cNvSpPr txBox="1"/>
           <p:nvPr/>
         </p:nvSpPr>
@@ -3226,7 +3191,7 @@
               </a:spcAft>
               <a:defRPr sz="4400" b="1">
                 <a:solidFill>
-                  <a:srgbClr val="FFFFFF"/>
+                  <a:srgbClr val="FAFAFA"/>
                 </a:solidFill>
               </a:defRPr>
             </a:pPr>
@@ -3241,19 +3206,19 @@
               </a:spcAft>
               <a:defRPr sz="2000">
                 <a:solidFill>
+                  <a:srgbClr val="38BDF8"/>
+                </a:solidFill>
+              </a:defRPr>
+            </a:pPr>
+            <a:r>
+              <a:t>Relational Modeling, Interactive E-Reader, Federated OAuth &amp; Apple-Inspired Architecture</a:t>
+            </a:r>
+          </a:p>
+          <a:p>
+            <a:pPr>
+              <a:defRPr sz="1200">
+                <a:solidFill>
                   <a:srgbClr val="A1A1AA"/>
-                </a:solidFill>
-              </a:defRPr>
-            </a:pPr>
-            <a:r>
-              <a:t>Relational Modeling, Open-Access E-Reader, Federated OAuth &amp; Apple-Inspired UI</a:t>
-            </a:r>
-          </a:p>
-          <a:p>
-            <a:pPr>
-              <a:defRPr sz="1200">
-                <a:solidFill>
-                  <a:srgbClr val="71717A"/>
                 </a:solidFill>
               </a:defRPr>
             </a:pPr>
@@ -3274,6 +3239,14 @@
 <file path=ppt/slides/slide10.xml><?xml version="1.0" encoding="utf-8"?>
 <p:sld xmlns:a="http://schemas.openxmlformats.org/drawingml/2006/main" xmlns:p="http://schemas.openxmlformats.org/presentationml/2006/main" xmlns:r="http://schemas.openxmlformats.org/officeDocument/2006/relationships">
   <p:cSld>
+    <p:bg>
+      <p:bgPr>
+        <a:solidFill>
+          <a:srgbClr val="09090B"/>
+        </a:solidFill>
+        <a:effectLst/>
+      </p:bgPr>
+    </p:bg>
     <p:spTree>
       <p:nvGrpSpPr>
         <p:cNvPr id="1" name=""/>
@@ -3283,44 +3256,36 @@
       <p:grpSpPr/>
       <p:sp>
         <p:nvSpPr>
-          <p:cNvPr id="2" name="Rectangle 1"/>
-          <p:cNvSpPr/>
+          <p:cNvPr id="2" name="TextBox 1"/>
+          <p:cNvSpPr txBox="1"/>
           <p:nvPr/>
         </p:nvSpPr>
         <p:spPr>
           <a:xfrm>
-            <a:off x="0" y="0"/>
-            <a:ext cx="12191695" cy="6858000"/>
+            <a:off x="731520" y="502920"/>
+            <a:ext cx="10698480" cy="365760"/>
           </a:xfrm>
           <a:prstGeom prst="rect">
             <a:avLst/>
           </a:prstGeom>
-          <a:solidFill>
-            <a:srgbClr val="F8FAFC"/>
-          </a:solidFill>
-          <a:ln>
-            <a:noFill/>
-          </a:ln>
-        </p:spPr>
-        <p:style>
-          <a:lnRef idx="1">
-            <a:schemeClr val="accent1"/>
-          </a:lnRef>
-          <a:fillRef idx="3">
-            <a:schemeClr val="accent1"/>
-          </a:fillRef>
-          <a:effectRef idx="2">
-            <a:schemeClr val="accent1"/>
-          </a:effectRef>
-          <a:fontRef idx="minor">
-            <a:schemeClr val="lt1"/>
-          </a:fontRef>
-        </p:style>
-        <p:txBody>
-          <a:bodyPr rtlCol="0" anchor="ctr"/>
-          <a:lstStyle/>
-          <a:p>
-            <a:pPr algn="ctr"/>
+          <a:noFill/>
+        </p:spPr>
+        <p:txBody>
+          <a:bodyPr wrap="square">
+            <a:spAutoFit/>
+          </a:bodyPr>
+          <a:lstStyle/>
+          <a:p>
+            <a:pPr>
+              <a:defRPr sz="1100" b="1">
+                <a:solidFill>
+                  <a:srgbClr val="0071E3"/>
+                </a:solidFill>
+              </a:defRPr>
+            </a:pPr>
+            <a:r>
+              <a:t>DEPLOYMENT &amp; PROJECT CONCLUSION</a:t>
+            </a:r>
           </a:p>
         </p:txBody>
       </p:sp>
@@ -3332,8 +3297,8 @@
         </p:nvSpPr>
         <p:spPr>
           <a:xfrm>
-            <a:off x="731520" y="457200"/>
-            <a:ext cx="10698480" cy="1005840"/>
+            <a:off x="731520" y="777240"/>
+            <a:ext cx="10698480" cy="731520"/>
           </a:xfrm>
           <a:prstGeom prst="rect">
             <a:avLst/>
@@ -3347,29 +3312,14 @@
           <a:lstStyle/>
           <a:p>
             <a:pPr>
-              <a:spcAft>
-                <a:spcPts val="400"/>
-              </a:spcAft>
-              <a:defRPr sz="1100" b="1">
-                <a:solidFill>
-                  <a:srgbClr val="0071E3"/>
-                </a:solidFill>
-              </a:defRPr>
-            </a:pPr>
-            <a:r>
-              <a:t>DEPLOYMENT &amp; PROJECT SUMMARY</a:t>
-            </a:r>
-          </a:p>
-          <a:p>
-            <a:pPr>
-              <a:defRPr sz="2500" b="1">
-                <a:solidFill>
-                  <a:srgbClr val="0F172A"/>
-                </a:solidFill>
-              </a:defRPr>
-            </a:pPr>
-            <a:r>
-              <a:t>Deployment, Key DBMS Learnings &amp; Verification</a:t>
+              <a:defRPr sz="2600" b="1">
+                <a:solidFill>
+                  <a:srgbClr val="FAFAFA"/>
+                </a:solidFill>
+              </a:defRPr>
+            </a:pPr>
+            <a:r>
+              <a:t>System Summary &amp; Verification Details</a:t>
             </a:r>
           </a:p>
         </p:txBody>
@@ -3389,11 +3339,11 @@
             <a:avLst/>
           </a:prstGeom>
           <a:solidFill>
-            <a:srgbClr val="FFFFFF"/>
+            <a:srgbClr val="141418"/>
           </a:solidFill>
-          <a:ln w="12700">
+          <a:ln w="15240">
             <a:solidFill>
-              <a:srgbClr val="E2E8F0"/>
+              <a:srgbClr val="27272E"/>
             </a:solidFill>
           </a:ln>
         </p:spPr>
@@ -3490,12 +3440,12 @@
               </a:spcAft>
               <a:defRPr sz="1700" b="1">
                 <a:solidFill>
-                  <a:srgbClr val="0F172A"/>
-                </a:solidFill>
-              </a:defRPr>
-            </a:pPr>
-            <a:r>
-              <a:t>Core DBMS Takeaways</a:t>
+                  <a:srgbClr val="FAFAFA"/>
+                </a:solidFill>
+              </a:defRPr>
+            </a:pPr>
+            <a:r>
+              <a:t>DBMS Academic Requirements Met</a:t>
             </a:r>
           </a:p>
           <a:p>
@@ -3505,12 +3455,12 @@
               </a:spcAft>
               <a:defRPr sz="1200">
                 <a:solidFill>
-                  <a:srgbClr val="64748B"/>
-                </a:solidFill>
-              </a:defRPr>
-            </a:pPr>
-            <a:r>
-              <a:t>• Domain Realism: Decoupling titles from physical copies is the golden standard for lending systems.</a:t>
+                  <a:srgbClr val="A1A1AA"/>
+                </a:solidFill>
+              </a:defRPr>
+            </a:pPr>
+            <a:r>
+              <a:t>• Normalization: Third Normal Form (3NF) relational design with zero data redundancy.</a:t>
             </a:r>
           </a:p>
           <a:p>
@@ -3520,12 +3470,12 @@
               </a:spcAft>
               <a:defRPr sz="1200">
                 <a:solidFill>
-                  <a:srgbClr val="64748B"/>
-                </a:solidFill>
-              </a:defRPr>
-            </a:pPr>
-            <a:r>
-              <a:t>• ACID over Client-Side Checks: Enforcing consistency inside database transactions prevents phantom states.</a:t>
+                  <a:srgbClr val="A1A1AA"/>
+                </a:solidFill>
+              </a:defRPr>
+            </a:pPr>
+            <a:r>
+              <a:t>• ACID Concurrency: Write-Ahead Logging (WAL), atomic transactions, and partial unique indexes.</a:t>
             </a:r>
           </a:p>
           <a:p>
@@ -3535,12 +3485,12 @@
               </a:spcAft>
               <a:defRPr sz="1200">
                 <a:solidFill>
-                  <a:srgbClr val="64748B"/>
-                </a:solidFill>
-              </a:defRPr>
-            </a:pPr>
-            <a:r>
-              <a:t>• Indexes Matter: Partial unique indexes provide bulletproof business constraints without heavy table triggers.</a:t>
+                  <a:srgbClr val="A1A1AA"/>
+                </a:solidFill>
+              </a:defRPr>
+            </a:pPr>
+            <a:r>
+              <a:t>• Integrity Constraints: ON DELETE CASCADE, CHECK constraints, and non-nullable keys.</a:t>
             </a:r>
           </a:p>
           <a:p>
@@ -3550,12 +3500,12 @@
               </a:spcAft>
               <a:defRPr sz="1200">
                 <a:solidFill>
-                  <a:srgbClr val="64748B"/>
-                </a:solidFill>
-              </a:defRPr>
-            </a:pPr>
-            <a:r>
-              <a:t>• Full-Stack Synergy: TypeScript end-to-end creates reliable contracts between React UI and the SQL engine.</a:t>
+                  <a:srgbClr val="A1A1AA"/>
+                </a:solidFill>
+              </a:defRPr>
+            </a:pPr>
+            <a:r>
+              <a:t>• Auditability: Immutable circulation ledger tracking every checkout, return, extension, and fine.</a:t>
             </a:r>
           </a:p>
         </p:txBody>
@@ -3575,11 +3525,11 @@
             <a:avLst/>
           </a:prstGeom>
           <a:solidFill>
-            <a:srgbClr val="FFFFFF"/>
+            <a:srgbClr val="141418"/>
           </a:solidFill>
-          <a:ln w="12700">
+          <a:ln w="15240">
             <a:solidFill>
-              <a:srgbClr val="E2E8F0"/>
+              <a:srgbClr val="27272E"/>
             </a:solidFill>
           </a:ln>
         </p:spPr>
@@ -3620,7 +3570,7 @@
             <a:avLst/>
           </a:prstGeom>
           <a:solidFill>
-            <a:srgbClr val="4F46E5"/>
+            <a:srgbClr val="8B5CF6"/>
           </a:solidFill>
           <a:ln>
             <a:noFill/>
@@ -3676,12 +3626,12 @@
               </a:spcAft>
               <a:defRPr sz="1700" b="1">
                 <a:solidFill>
-                  <a:srgbClr val="0F172A"/>
-                </a:solidFill>
-              </a:defRPr>
-            </a:pPr>
-            <a:r>
-              <a:t>Native Hosting &amp; Reproducibility</a:t>
+                  <a:srgbClr val="FAFAFA"/>
+                </a:solidFill>
+              </a:defRPr>
+            </a:pPr>
+            <a:r>
+              <a:t>Live Production Deployment</a:t>
             </a:r>
           </a:p>
           <a:p>
@@ -3691,12 +3641,12 @@
               </a:spcAft>
               <a:defRPr sz="1200">
                 <a:solidFill>
-                  <a:srgbClr val="64748B"/>
-                </a:solidFill>
-              </a:defRPr>
-            </a:pPr>
-            <a:r>
-              <a:t>• GitHub Repository: Fully version-controlled codebase hosted at themellowhost/library-lending-system.</a:t>
+                  <a:srgbClr val="A1A1AA"/>
+                </a:solidFill>
+              </a:defRPr>
+            </a:pPr>
+            <a:r>
+              <a:t>• Production App: https://themellowhost.github.io/library-lending-system/</a:t>
             </a:r>
           </a:p>
           <a:p>
@@ -3706,12 +3656,12 @@
               </a:spcAft>
               <a:defRPr sz="1200">
                 <a:solidFill>
-                  <a:srgbClr val="64748B"/>
-                </a:solidFill>
-              </a:defRPr>
-            </a:pPr>
-            <a:r>
-              <a:t>• GitHub Pages Live Deployment: Automated GitHub Actions CI/CD workflow deploying frontend directly on git push.</a:t>
+                  <a:srgbClr val="A1A1AA"/>
+                </a:solidFill>
+              </a:defRPr>
+            </a:pPr>
+            <a:r>
+              <a:t>• GitHub Repository: https://github.com/themellowhost/library-lending-system</a:t>
             </a:r>
           </a:p>
           <a:p>
@@ -3721,12 +3671,12 @@
               </a:spcAft>
               <a:defRPr sz="1200">
                 <a:solidFill>
-                  <a:srgbClr val="64748B"/>
-                </a:solidFill>
-              </a:defRPr>
-            </a:pPr>
-            <a:r>
-              <a:t>• Dual-Engine Execution: Seamlessly operates connected to local SQLite server OR standalone on GitHub Pages via resilient mock engine.</a:t>
+                  <a:srgbClr val="A1A1AA"/>
+                </a:solidFill>
+              </a:defRPr>
+            </a:pPr>
+            <a:r>
+              <a:t>• Full Persona Testing: One-click switcher between Member (Alex), Librarian (Elena), and Admin (Marcus).</a:t>
             </a:r>
           </a:p>
           <a:p>
@@ -3736,12 +3686,12 @@
               </a:spcAft>
               <a:defRPr sz="1200">
                 <a:solidFill>
-                  <a:srgbClr val="64748B"/>
-                </a:solidFill>
-              </a:defRPr>
-            </a:pPr>
-            <a:r>
-              <a:t>• Dockerized Environment: Single-command deployment via Docker Compose with volume-mounted databases.</a:t>
+                  <a:srgbClr val="A1A1AA"/>
+                </a:solidFill>
+              </a:defRPr>
+            </a:pPr>
+            <a:r>
+              <a:t>• Dual-Mode Architecture: Full operational capability on static hosting via resilient client fallback engine.</a:t>
             </a:r>
           </a:p>
         </p:txBody>
@@ -3757,6 +3707,14 @@
 <file path=ppt/slides/slide2.xml><?xml version="1.0" encoding="utf-8"?>
 <p:sld xmlns:a="http://schemas.openxmlformats.org/drawingml/2006/main" xmlns:p="http://schemas.openxmlformats.org/presentationml/2006/main" xmlns:r="http://schemas.openxmlformats.org/officeDocument/2006/relationships">
   <p:cSld>
+    <p:bg>
+      <p:bgPr>
+        <a:solidFill>
+          <a:srgbClr val="09090B"/>
+        </a:solidFill>
+        <a:effectLst/>
+      </p:bgPr>
+    </p:bg>
     <p:spTree>
       <p:nvGrpSpPr>
         <p:cNvPr id="1" name=""/>
@@ -3766,44 +3724,36 @@
       <p:grpSpPr/>
       <p:sp>
         <p:nvSpPr>
-          <p:cNvPr id="2" name="Rectangle 1"/>
-          <p:cNvSpPr/>
+          <p:cNvPr id="2" name="TextBox 1"/>
+          <p:cNvSpPr txBox="1"/>
           <p:nvPr/>
         </p:nvSpPr>
         <p:spPr>
           <a:xfrm>
-            <a:off x="0" y="0"/>
-            <a:ext cx="12191695" cy="6858000"/>
+            <a:off x="731520" y="502920"/>
+            <a:ext cx="10698480" cy="365760"/>
           </a:xfrm>
           <a:prstGeom prst="rect">
             <a:avLst/>
           </a:prstGeom>
-          <a:solidFill>
-            <a:srgbClr val="F8FAFC"/>
-          </a:solidFill>
-          <a:ln>
-            <a:noFill/>
-          </a:ln>
-        </p:spPr>
-        <p:style>
-          <a:lnRef idx="1">
-            <a:schemeClr val="accent1"/>
-          </a:lnRef>
-          <a:fillRef idx="3">
-            <a:schemeClr val="accent1"/>
-          </a:fillRef>
-          <a:effectRef idx="2">
-            <a:schemeClr val="accent1"/>
-          </a:effectRef>
-          <a:fontRef idx="minor">
-            <a:schemeClr val="lt1"/>
-          </a:fontRef>
-        </p:style>
-        <p:txBody>
-          <a:bodyPr rtlCol="0" anchor="ctr"/>
-          <a:lstStyle/>
-          <a:p>
-            <a:pPr algn="ctr"/>
+          <a:noFill/>
+        </p:spPr>
+        <p:txBody>
+          <a:bodyPr wrap="square">
+            <a:spAutoFit/>
+          </a:bodyPr>
+          <a:lstStyle/>
+          <a:p>
+            <a:pPr>
+              <a:defRPr sz="1100" b="1">
+                <a:solidFill>
+                  <a:srgbClr val="0071E3"/>
+                </a:solidFill>
+              </a:defRPr>
+            </a:pPr>
+            <a:r>
+              <a:t>SYSTEM REQUIREMENTS &amp; CORE DOMAIN</a:t>
+            </a:r>
           </a:p>
         </p:txBody>
       </p:sp>
@@ -3815,8 +3765,8 @@
         </p:nvSpPr>
         <p:spPr>
           <a:xfrm>
-            <a:off x="731520" y="457200"/>
-            <a:ext cx="10698480" cy="1005840"/>
+            <a:off x="731520" y="777240"/>
+            <a:ext cx="10698480" cy="731520"/>
           </a:xfrm>
           <a:prstGeom prst="rect">
             <a:avLst/>
@@ -3830,24 +3780,9 @@
           <a:lstStyle/>
           <a:p>
             <a:pPr>
-              <a:spcAft>
-                <a:spcPts val="400"/>
-              </a:spcAft>
-              <a:defRPr sz="1100" b="1">
-                <a:solidFill>
-                  <a:srgbClr val="0071E3"/>
-                </a:solidFill>
-              </a:defRPr>
-            </a:pPr>
-            <a:r>
-              <a:t>SYSTEM REQUIREMENTS &amp; CORE DOMAIN</a:t>
-            </a:r>
-          </a:p>
-          <a:p>
-            <a:pPr>
-              <a:defRPr sz="2500" b="1">
-                <a:solidFill>
-                  <a:srgbClr val="0F172A"/>
+              <a:defRPr sz="2600" b="1">
+                <a:solidFill>
+                  <a:srgbClr val="FAFAFA"/>
                 </a:solidFill>
               </a:defRPr>
             </a:pPr>
@@ -3872,11 +3807,11 @@
             <a:avLst/>
           </a:prstGeom>
           <a:solidFill>
-            <a:srgbClr val="FFFFFF"/>
+            <a:srgbClr val="141418"/>
           </a:solidFill>
-          <a:ln w="12700">
+          <a:ln w="15240">
             <a:solidFill>
-              <a:srgbClr val="E2E8F0"/>
+              <a:srgbClr val="27272E"/>
             </a:solidFill>
           </a:ln>
         </p:spPr>
@@ -3973,12 +3908,12 @@
               </a:spcAft>
               <a:defRPr sz="1700" b="1">
                 <a:solidFill>
-                  <a:srgbClr val="0F172A"/>
-                </a:solidFill>
-              </a:defRPr>
-            </a:pPr>
-            <a:r>
-              <a:t>The Domain Challenge</a:t>
+                  <a:srgbClr val="FAFAFA"/>
+                </a:solidFill>
+              </a:defRPr>
+            </a:pPr>
+            <a:r>
+              <a:t>The Core Domain Challenge</a:t>
             </a:r>
           </a:p>
           <a:p>
@@ -3988,12 +3923,12 @@
               </a:spcAft>
               <a:defRPr sz="1200">
                 <a:solidFill>
-                  <a:srgbClr val="64748B"/>
-                </a:solidFill>
-              </a:defRPr>
-            </a:pPr>
-            <a:r>
-              <a:t>• A library does not lend abstract titles; it lends individual physical items with barcodes.</a:t>
+                  <a:srgbClr val="A1A1AA"/>
+                </a:solidFill>
+              </a:defRPr>
+            </a:pPr>
+            <a:r>
+              <a:t>• A library does not lend abstract titles; it lends physical barcoded items placed on distinct shelves.</a:t>
             </a:r>
           </a:p>
           <a:p>
@@ -4003,12 +3938,12 @@
               </a:spcAft>
               <a:defRPr sz="1200">
                 <a:solidFill>
-                  <a:srgbClr val="64748B"/>
-                </a:solidFill>
-              </a:defRPr>
-            </a:pPr>
-            <a:r>
-              <a:t>• Naive library systems merge books and inventory, leading to severe data anomalies.</a:t>
+                  <a:srgbClr val="A1A1AA"/>
+                </a:solidFill>
+              </a:defRPr>
+            </a:pPr>
+            <a:r>
+              <a:t>• Naive systems merge catalog entries and physical stock, leading to severe data anomalies and inventory loss.</a:t>
             </a:r>
           </a:p>
           <a:p>
@@ -4018,12 +3953,12 @@
               </a:spcAft>
               <a:defRPr sz="1200">
                 <a:solidFill>
-                  <a:srgbClr val="64748B"/>
-                </a:solidFill>
-              </a:defRPr>
-            </a:pPr>
-            <a:r>
-              <a:t>• Requirements encompass 3 distinct user roles: Member, Librarian, and Administrator.</a:t>
+                  <a:srgbClr val="A1A1AA"/>
+                </a:solidFill>
+              </a:defRPr>
+            </a:pPr>
+            <a:r>
+              <a:t>• Circulation demands strict transactional ACID guarantees to eliminate concurrent double-booking.</a:t>
             </a:r>
           </a:p>
           <a:p>
@@ -4033,12 +3968,12 @@
               </a:spcAft>
               <a:defRPr sz="1200">
                 <a:solidFill>
-                  <a:srgbClr val="64748B"/>
-                </a:solidFill>
-              </a:defRPr>
-            </a:pPr>
-            <a:r>
-              <a:t>• Circulation needs strict transactional enforcement to avoid concurrent double-booking.</a:t>
+                  <a:srgbClr val="A1A1AA"/>
+                </a:solidFill>
+              </a:defRPr>
+            </a:pPr>
+            <a:r>
+              <a:t>• Students require self-service reservations and loan extensions with duty librarian approval oversight.</a:t>
             </a:r>
           </a:p>
         </p:txBody>
@@ -4058,11 +3993,11 @@
             <a:avLst/>
           </a:prstGeom>
           <a:solidFill>
-            <a:srgbClr val="FFFFFF"/>
+            <a:srgbClr val="141418"/>
           </a:solidFill>
-          <a:ln w="12700">
+          <a:ln w="15240">
             <a:solidFill>
-              <a:srgbClr val="E2E8F0"/>
+              <a:srgbClr val="27272E"/>
             </a:solidFill>
           </a:ln>
         </p:spPr>
@@ -4103,7 +4038,7 @@
             <a:avLst/>
           </a:prstGeom>
           <a:solidFill>
-            <a:srgbClr val="4F46E5"/>
+            <a:srgbClr val="8B5CF6"/>
           </a:solidFill>
           <a:ln>
             <a:noFill/>
@@ -4159,7 +4094,7 @@
               </a:spcAft>
               <a:defRPr sz="1700" b="1">
                 <a:solidFill>
-                  <a:srgbClr val="0F172A"/>
+                  <a:srgbClr val="FAFAFA"/>
                 </a:solidFill>
               </a:defRPr>
             </a:pPr>
@@ -4174,7 +4109,7 @@
               </a:spcAft>
               <a:defRPr sz="1200">
                 <a:solidFill>
-                  <a:srgbClr val="64748B"/>
+                  <a:srgbClr val="A1A1AA"/>
                 </a:solidFill>
               </a:defRPr>
             </a:pPr>
@@ -4189,12 +4124,12 @@
               </a:spcAft>
               <a:defRPr sz="1200">
                 <a:solidFill>
-                  <a:srgbClr val="64748B"/>
-                </a:solidFill>
-              </a:defRPr>
-            </a:pPr>
-            <a:r>
-              <a:t>• Copy Entity (Physical Item): Barcode, Shelf Location, Lending Status ('available', 'on_loan', 'on_hold').</a:t>
+                  <a:srgbClr val="A1A1AA"/>
+                </a:solidFill>
+              </a:defRPr>
+            </a:pPr>
+            <a:r>
+              <a:t>• Copy Entity (Physical Item): Asset Barcode, Shelf Location, Status ('available', 'on_loan', 'on_hold').</a:t>
             </a:r>
           </a:p>
           <a:p>
@@ -4204,12 +4139,12 @@
               </a:spcAft>
               <a:defRPr sz="1200">
                 <a:solidFill>
-                  <a:srgbClr val="64748B"/>
-                </a:solidFill>
-              </a:defRPr>
-            </a:pPr>
-            <a:r>
-              <a:t>• Scalability: 1 title can have 10 physical copies across multiple library floors with independent circulation lifecycles.</a:t>
+                  <a:srgbClr val="A1A1AA"/>
+                </a:solidFill>
+              </a:defRPr>
+            </a:pPr>
+            <a:r>
+              <a:t>• Scalability: 1 title seamlessly scales to 10+ physical copies across library stacks with independent circulation.</a:t>
             </a:r>
           </a:p>
           <a:p>
@@ -4219,12 +4154,12 @@
               </a:spcAft>
               <a:defRPr sz="1200">
                 <a:solidFill>
-                  <a:srgbClr val="64748B"/>
-                </a:solidFill>
-              </a:defRPr>
-            </a:pPr>
-            <a:r>
-              <a:t>• Digital Hybrid: Physical copies circulate via barcode transactions while digital editions stream via online readers.</a:t>
+                  <a:srgbClr val="A1A1AA"/>
+                </a:solidFill>
+              </a:defRPr>
+            </a:pPr>
+            <a:r>
+              <a:t>• Digital Hybrid: Physical copies circulate via barcode transactions while digital editions stream via online e-readers.</a:t>
             </a:r>
           </a:p>
         </p:txBody>
@@ -4240,6 +4175,14 @@
 <file path=ppt/slides/slide3.xml><?xml version="1.0" encoding="utf-8"?>
 <p:sld xmlns:a="http://schemas.openxmlformats.org/drawingml/2006/main" xmlns:p="http://schemas.openxmlformats.org/presentationml/2006/main" xmlns:r="http://schemas.openxmlformats.org/officeDocument/2006/relationships">
   <p:cSld>
+    <p:bg>
+      <p:bgPr>
+        <a:solidFill>
+          <a:srgbClr val="09090B"/>
+        </a:solidFill>
+        <a:effectLst/>
+      </p:bgPr>
+    </p:bg>
     <p:spTree>
       <p:nvGrpSpPr>
         <p:cNvPr id="1" name=""/>
@@ -4249,44 +4192,36 @@
       <p:grpSpPr/>
       <p:sp>
         <p:nvSpPr>
-          <p:cNvPr id="2" name="Rectangle 1"/>
-          <p:cNvSpPr/>
+          <p:cNvPr id="2" name="TextBox 1"/>
+          <p:cNvSpPr txBox="1"/>
           <p:nvPr/>
         </p:nvSpPr>
         <p:spPr>
           <a:xfrm>
-            <a:off x="0" y="0"/>
-            <a:ext cx="12191695" cy="6858000"/>
+            <a:off x="731520" y="502920"/>
+            <a:ext cx="10698480" cy="365760"/>
           </a:xfrm>
           <a:prstGeom prst="rect">
             <a:avLst/>
           </a:prstGeom>
-          <a:solidFill>
-            <a:srgbClr val="F8FAFC"/>
-          </a:solidFill>
-          <a:ln>
-            <a:noFill/>
-          </a:ln>
-        </p:spPr>
-        <p:style>
-          <a:lnRef idx="1">
-            <a:schemeClr val="accent1"/>
-          </a:lnRef>
-          <a:fillRef idx="3">
-            <a:schemeClr val="accent1"/>
-          </a:fillRef>
-          <a:effectRef idx="2">
-            <a:schemeClr val="accent1"/>
-          </a:effectRef>
-          <a:fontRef idx="minor">
-            <a:schemeClr val="lt1"/>
-          </a:fontRef>
-        </p:style>
-        <p:txBody>
-          <a:bodyPr rtlCol="0" anchor="ctr"/>
-          <a:lstStyle/>
-          <a:p>
-            <a:pPr algn="ctr"/>
+          <a:noFill/>
+        </p:spPr>
+        <p:txBody>
+          <a:bodyPr wrap="square">
+            <a:spAutoFit/>
+          </a:bodyPr>
+          <a:lstStyle/>
+          <a:p>
+            <a:pPr>
+              <a:defRPr sz="1100" b="1">
+                <a:solidFill>
+                  <a:srgbClr val="0071E3"/>
+                </a:solidFill>
+              </a:defRPr>
+            </a:pPr>
+            <a:r>
+              <a:t>ARCHITECTURE DECISION RECORD (ADR)</a:t>
+            </a:r>
           </a:p>
         </p:txBody>
       </p:sp>
@@ -4298,8 +4233,8 @@
         </p:nvSpPr>
         <p:spPr>
           <a:xfrm>
-            <a:off x="731520" y="457200"/>
-            <a:ext cx="10698480" cy="1005840"/>
+            <a:off x="731520" y="777240"/>
+            <a:ext cx="10698480" cy="731520"/>
           </a:xfrm>
           <a:prstGeom prst="rect">
             <a:avLst/>
@@ -4313,29 +4248,14 @@
           <a:lstStyle/>
           <a:p>
             <a:pPr>
-              <a:spcAft>
-                <a:spcPts val="400"/>
-              </a:spcAft>
-              <a:defRPr sz="1100" b="1">
-                <a:solidFill>
-                  <a:srgbClr val="0071E3"/>
-                </a:solidFill>
-              </a:defRPr>
-            </a:pPr>
-            <a:r>
-              <a:t>ARCHITECTURE DECISION RECORD (ADR)</a:t>
-            </a:r>
-          </a:p>
-          <a:p>
-            <a:pPr>
-              <a:defRPr sz="2500" b="1">
-                <a:solidFill>
-                  <a:srgbClr val="0F172A"/>
-                </a:solidFill>
-              </a:defRPr>
-            </a:pPr>
-            <a:r>
-              <a:t>Technology Stack: What We Used and Why</a:t>
+              <a:defRPr sz="2600" b="1">
+                <a:solidFill>
+                  <a:srgbClr val="FAFAFA"/>
+                </a:solidFill>
+              </a:defRPr>
+            </a:pPr>
+            <a:r>
+              <a:t>Technology Stack: Selection Rationale &amp; Advantages</a:t>
             </a:r>
           </a:p>
         </p:txBody>
@@ -4355,11 +4275,11 @@
             <a:avLst/>
           </a:prstGeom>
           <a:solidFill>
-            <a:srgbClr val="FFFFFF"/>
+            <a:srgbClr val="141418"/>
           </a:solidFill>
-          <a:ln w="12700">
+          <a:ln w="15240">
             <a:solidFill>
-              <a:srgbClr val="E2E8F0"/>
+              <a:srgbClr val="27272E"/>
             </a:solidFill>
           </a:ln>
         </p:spPr>
@@ -4456,7 +4376,7 @@
               </a:spcAft>
               <a:defRPr sz="1500" b="1">
                 <a:solidFill>
-                  <a:srgbClr val="0F172A"/>
+                  <a:srgbClr val="FAFAFA"/>
                 </a:solidFill>
               </a:defRPr>
             </a:pPr>
@@ -4486,12 +4406,12 @@
               </a:spcAft>
               <a:defRPr sz="1100">
                 <a:solidFill>
-                  <a:srgbClr val="64748B"/>
-                </a:solidFill>
-              </a:defRPr>
-            </a:pPr>
-            <a:r>
-              <a:t>• Apple Design Language: Dark frosted glass (.apple-glass), SF Pro fonts, and pill buttons.</a:t>
+                  <a:srgbClr val="A1A1AA"/>
+                </a:solidFill>
+              </a:defRPr>
+            </a:pPr>
+            <a:r>
+              <a:t>• Apple Dark Aesthetics: Apple glass (.apple-glass), SF Pro fonts, and pill buttons.</a:t>
             </a:r>
           </a:p>
           <a:p>
@@ -4501,12 +4421,12 @@
               </a:spcAft>
               <a:defRPr sz="1100">
                 <a:solidFill>
-                  <a:srgbClr val="64748B"/>
-                </a:solidFill>
-              </a:defRPr>
-            </a:pPr>
-            <a:r>
-              <a:t>• Interactive Digital E-Reader: Fast-embedded 2-page reader canvas with theater fullscreen mode.</a:t>
+                  <a:srgbClr val="A1A1AA"/>
+                </a:solidFill>
+              </a:defRPr>
+            </a:pPr>
+            <a:r>
+              <a:t>• Fast E-Reader: Direct embedded 2-page reader canvas with 86vh viewport.</a:t>
             </a:r>
           </a:p>
           <a:p>
@@ -4516,12 +4436,12 @@
               </a:spcAft>
               <a:defRPr sz="1100">
                 <a:solidFill>
-                  <a:srgbClr val="64748B"/>
-                </a:solidFill>
-              </a:defRPr>
-            </a:pPr>
-            <a:r>
-              <a:t>• Federated OAuth: One-click Sign In with Apple and Google with official brand SVGs.</a:t>
+                  <a:srgbClr val="A1A1AA"/>
+                </a:solidFill>
+              </a:defRPr>
+            </a:pPr>
+            <a:r>
+              <a:t>• Federated OAuth: One-click Sign In with Apple and Google with official brand vector SVGs.</a:t>
             </a:r>
           </a:p>
           <a:p>
@@ -4531,12 +4451,12 @@
               </a:spcAft>
               <a:defRPr sz="1100">
                 <a:solidFill>
-                  <a:srgbClr val="64748B"/>
-                </a:solidFill>
-              </a:defRPr>
-            </a:pPr>
-            <a:r>
-              <a:t>• Dual-Mode Resilience: Instant client-side fallback store enabling seamless static GitHub Pages hosting.</a:t>
+                  <a:srgbClr val="A1A1AA"/>
+                </a:solidFill>
+              </a:defRPr>
+            </a:pPr>
+            <a:r>
+              <a:t>• Static Deployment Resilience: In-memory runtime engine enabling full functionality on GitHub Pages.</a:t>
             </a:r>
           </a:p>
         </p:txBody>
@@ -4556,11 +4476,11 @@
             <a:avLst/>
           </a:prstGeom>
           <a:solidFill>
-            <a:srgbClr val="FFFFFF"/>
+            <a:srgbClr val="141418"/>
           </a:solidFill>
-          <a:ln w="12700">
+          <a:ln w="15240">
             <a:solidFill>
-              <a:srgbClr val="E2E8F0"/>
+              <a:srgbClr val="27272E"/>
             </a:solidFill>
           </a:ln>
         </p:spPr>
@@ -4601,7 +4521,7 @@
             <a:avLst/>
           </a:prstGeom>
           <a:solidFill>
-            <a:srgbClr val="4F46E5"/>
+            <a:srgbClr val="8B5CF6"/>
           </a:solidFill>
           <a:ln>
             <a:noFill/>
@@ -4657,7 +4577,7 @@
               </a:spcAft>
               <a:defRPr sz="1500" b="1">
                 <a:solidFill>
-                  <a:srgbClr val="0F172A"/>
+                  <a:srgbClr val="FAFAFA"/>
                 </a:solidFill>
               </a:defRPr>
             </a:pPr>
@@ -4672,7 +4592,7 @@
               </a:spcAft>
               <a:defRPr sz="1000" b="1">
                 <a:solidFill>
-                  <a:srgbClr val="4F46E5"/>
+                  <a:srgbClr val="8B5CF6"/>
                 </a:solidFill>
               </a:defRPr>
             </a:pPr>
@@ -4687,12 +4607,12 @@
               </a:spcAft>
               <a:defRPr sz="1100">
                 <a:solidFill>
-                  <a:srgbClr val="64748B"/>
-                </a:solidFill>
-              </a:defRPr>
-            </a:pPr>
-            <a:r>
-              <a:t>• Full TypeScript Stack: Shared data interfaces between client and server.</a:t>
+                  <a:srgbClr val="A1A1AA"/>
+                </a:solidFill>
+              </a:defRPr>
+            </a:pPr>
+            <a:r>
+              <a:t>• Full TypeScript Stack: Shared data interfaces between client, server, and schema models.</a:t>
             </a:r>
           </a:p>
           <a:p>
@@ -4702,12 +4622,12 @@
               </a:spcAft>
               <a:defRPr sz="1100">
                 <a:solidFill>
-                  <a:srgbClr val="64748B"/>
-                </a:solidFill>
-              </a:defRPr>
-            </a:pPr>
-            <a:r>
-              <a:t>• Open Library Integration: Live search proxy querying millions of public-domain books.</a:t>
+                  <a:srgbClr val="A1A1AA"/>
+                </a:solidFill>
+              </a:defRPr>
+            </a:pPr>
+            <a:r>
+              <a:t>• Open Library Integration: Live ISBN auto-lookup and open-access search for millions of public books.</a:t>
             </a:r>
           </a:p>
           <a:p>
@@ -4717,12 +4637,12 @@
               </a:spcAft>
               <a:defRPr sz="1100">
                 <a:solidFill>
-                  <a:srgbClr val="64748B"/>
-                </a:solidFill>
-              </a:defRPr>
-            </a:pPr>
-            <a:r>
-              <a:t>• Bcrypt &amp; JWT Auth: Industry-standard 10-round salted password hashing with signed tokens.</a:t>
+                  <a:srgbClr val="A1A1AA"/>
+                </a:solidFill>
+              </a:defRPr>
+            </a:pPr>
+            <a:r>
+              <a:t>• Bcrypt &amp; JWT Auth: Salted password hashing with signed authorization tokens.</a:t>
             </a:r>
           </a:p>
           <a:p>
@@ -4732,12 +4652,12 @@
               </a:spcAft>
               <a:defRPr sz="1100">
                 <a:solidFill>
-                  <a:srgbClr val="64748B"/>
-                </a:solidFill>
-              </a:defRPr>
-            </a:pPr>
-            <a:r>
-              <a:t>• Background Worker: Automatic 60s reaper for expired hold queues.</a:t>
+                  <a:srgbClr val="A1A1AA"/>
+                </a:solidFill>
+              </a:defRPr>
+            </a:pPr>
+            <a:r>
+              <a:t>• Hold Reaper Worker: Automated 60s background daemon promoting waiting hold queues.</a:t>
             </a:r>
           </a:p>
         </p:txBody>
@@ -4757,11 +4677,11 @@
             <a:avLst/>
           </a:prstGeom>
           <a:solidFill>
-            <a:srgbClr val="FFFFFF"/>
+            <a:srgbClr val="141418"/>
           </a:solidFill>
-          <a:ln w="12700">
+          <a:ln w="15240">
             <a:solidFill>
-              <a:srgbClr val="E2E8F0"/>
+              <a:srgbClr val="27272E"/>
             </a:solidFill>
           </a:ln>
         </p:spPr>
@@ -4858,7 +4778,7 @@
               </a:spcAft>
               <a:defRPr sz="1500" b="1">
                 <a:solidFill>
-                  <a:srgbClr val="0F172A"/>
+                  <a:srgbClr val="FAFAFA"/>
                 </a:solidFill>
               </a:defRPr>
             </a:pPr>
@@ -4878,7 +4798,7 @@
               </a:defRPr>
             </a:pPr>
             <a:r>
-              <a:t>ACID Guarantees &amp; Partial Unique Indexes</a:t>
+              <a:t>ACID Transactions &amp; Partial Unique Indexes</a:t>
             </a:r>
           </a:p>
           <a:p>
@@ -4888,7 +4808,7 @@
               </a:spcAft>
               <a:defRPr sz="1100">
                 <a:solidFill>
-                  <a:srgbClr val="64748B"/>
+                  <a:srgbClr val="A1A1AA"/>
                 </a:solidFill>
               </a:defRPr>
             </a:pPr>
@@ -4903,12 +4823,12 @@
               </a:spcAft>
               <a:defRPr sz="1100">
                 <a:solidFill>
-                  <a:srgbClr val="64748B"/>
-                </a:solidFill>
-              </a:defRPr>
-            </a:pPr>
-            <a:r>
-              <a:t>• Write-Ahead Logging (WAL): Concurrency support for simultaneous reads and writes.</a:t>
+                  <a:srgbClr val="A1A1AA"/>
+                </a:solidFill>
+              </a:defRPr>
+            </a:pPr>
+            <a:r>
+              <a:t>• Write-Ahead Logging (WAL): Concurrency support for concurrent reads and writes.</a:t>
             </a:r>
           </a:p>
           <a:p>
@@ -4918,12 +4838,12 @@
               </a:spcAft>
               <a:defRPr sz="1100">
                 <a:solidFill>
-                  <a:srgbClr val="64748B"/>
-                </a:solidFill>
-              </a:defRPr>
-            </a:pPr>
-            <a:r>
-              <a:t>• Partial Unique Indexes: True DBMS-level constraints (e.g. 1 active loan per copy).</a:t>
+                  <a:srgbClr val="A1A1AA"/>
+                </a:solidFill>
+              </a:defRPr>
+            </a:pPr>
+            <a:r>
+              <a:t>• Partial Unique Indexes: True DBMS constraints (1 active loan per copy, 1 active hold per member).</a:t>
             </a:r>
           </a:p>
           <a:p>
@@ -4933,12 +4853,12 @@
               </a:spcAft>
               <a:defRPr sz="1100">
                 <a:solidFill>
-                  <a:srgbClr val="64748B"/>
-                </a:solidFill>
-              </a:defRPr>
-            </a:pPr>
-            <a:r>
-              <a:t>• Immutable Audit Log: Dedicated audit_logs table for all checkout, return, and renewal actions.</a:t>
+                  <a:srgbClr val="A1A1AA"/>
+                </a:solidFill>
+              </a:defRPr>
+            </a:pPr>
+            <a:r>
+              <a:t>• Audit Trail: Immutable audit_logs table for all checkouts, returns, extensions, and fine settlements.</a:t>
             </a:r>
           </a:p>
         </p:txBody>
@@ -4954,6 +4874,14 @@
 <file path=ppt/slides/slide4.xml><?xml version="1.0" encoding="utf-8"?>
 <p:sld xmlns:a="http://schemas.openxmlformats.org/drawingml/2006/main" xmlns:p="http://schemas.openxmlformats.org/presentationml/2006/main" xmlns:r="http://schemas.openxmlformats.org/officeDocument/2006/relationships">
   <p:cSld>
+    <p:bg>
+      <p:bgPr>
+        <a:solidFill>
+          <a:srgbClr val="09090B"/>
+        </a:solidFill>
+        <a:effectLst/>
+      </p:bgPr>
+    </p:bg>
     <p:spTree>
       <p:nvGrpSpPr>
         <p:cNvPr id="1" name=""/>
@@ -4963,44 +4891,36 @@
       <p:grpSpPr/>
       <p:sp>
         <p:nvSpPr>
-          <p:cNvPr id="2" name="Rectangle 1"/>
-          <p:cNvSpPr/>
+          <p:cNvPr id="2" name="TextBox 1"/>
+          <p:cNvSpPr txBox="1"/>
           <p:nvPr/>
         </p:nvSpPr>
         <p:spPr>
           <a:xfrm>
-            <a:off x="0" y="0"/>
-            <a:ext cx="12191695" cy="6858000"/>
+            <a:off x="731520" y="502920"/>
+            <a:ext cx="10698480" cy="365760"/>
           </a:xfrm>
           <a:prstGeom prst="rect">
             <a:avLst/>
           </a:prstGeom>
-          <a:solidFill>
-            <a:srgbClr val="F8FAFC"/>
-          </a:solidFill>
-          <a:ln>
-            <a:noFill/>
-          </a:ln>
-        </p:spPr>
-        <p:style>
-          <a:lnRef idx="1">
-            <a:schemeClr val="accent1"/>
-          </a:lnRef>
-          <a:fillRef idx="3">
-            <a:schemeClr val="accent1"/>
-          </a:fillRef>
-          <a:effectRef idx="2">
-            <a:schemeClr val="accent1"/>
-          </a:effectRef>
-          <a:fontRef idx="minor">
-            <a:schemeClr val="lt1"/>
-          </a:fontRef>
-        </p:style>
-        <p:txBody>
-          <a:bodyPr rtlCol="0" anchor="ctr"/>
-          <a:lstStyle/>
-          <a:p>
-            <a:pPr algn="ctr"/>
+          <a:noFill/>
+        </p:spPr>
+        <p:txBody>
+          <a:bodyPr wrap="square">
+            <a:spAutoFit/>
+          </a:bodyPr>
+          <a:lstStyle/>
+          <a:p>
+            <a:pPr>
+              <a:defRPr sz="1100" b="1">
+                <a:solidFill>
+                  <a:srgbClr val="0071E3"/>
+                </a:solidFill>
+              </a:defRPr>
+            </a:pPr>
+            <a:r>
+              <a:t>RELATIONAL DATABASE DESIGN • ENTITY RELATIONSHIPS</a:t>
+            </a:r>
           </a:p>
         </p:txBody>
       </p:sp>
@@ -5012,8 +4932,8 @@
         </p:nvSpPr>
         <p:spPr>
           <a:xfrm>
-            <a:off x="731520" y="457200"/>
-            <a:ext cx="10698480" cy="1005840"/>
+            <a:off x="731520" y="777240"/>
+            <a:ext cx="10698480" cy="731520"/>
           </a:xfrm>
           <a:prstGeom prst="rect">
             <a:avLst/>
@@ -5027,24 +4947,9 @@
           <a:lstStyle/>
           <a:p>
             <a:pPr>
-              <a:spcAft>
-                <a:spcPts val="400"/>
-              </a:spcAft>
-              <a:defRPr sz="1100" b="1">
-                <a:solidFill>
-                  <a:srgbClr val="0071E3"/>
-                </a:solidFill>
-              </a:defRPr>
-            </a:pPr>
-            <a:r>
-              <a:t>RELATIONAL DATABASE DESIGN • ENTITY RELATIONSHIPS</a:t>
-            </a:r>
-          </a:p>
-          <a:p>
-            <a:pPr>
-              <a:defRPr sz="2500" b="1">
-                <a:solidFill>
-                  <a:srgbClr val="0F172A"/>
+              <a:defRPr sz="2600" b="1">
+                <a:solidFill>
+                  <a:srgbClr val="FAFAFA"/>
                 </a:solidFill>
               </a:defRPr>
             </a:pPr>
@@ -5054,924 +4959,30 @@
           </a:p>
         </p:txBody>
       </p:sp>
-      <p:sp>
-        <p:nvSpPr>
-          <p:cNvPr id="4" name="Rounded Rectangle 3"/>
-          <p:cNvSpPr/>
+      <p:pic>
+        <p:nvPicPr>
+          <p:cNvPr id="4" name="Picture 3" descr="er_diagram_dark.png"/>
+          <p:cNvPicPr>
+            <a:picLocks noChangeAspect="1"/>
+          </p:cNvPicPr>
           <p:nvPr/>
-        </p:nvSpPr>
-        <p:spPr>
-          <a:xfrm>
-            <a:off x="731520" y="1645920"/>
-            <a:ext cx="3429000" cy="2194560"/>
-          </a:xfrm>
-          <a:prstGeom prst="roundRect">
-            <a:avLst/>
-          </a:prstGeom>
-          <a:solidFill>
-            <a:srgbClr val="FFFFFF"/>
-          </a:solidFill>
-          <a:ln w="12700">
-            <a:solidFill>
-              <a:srgbClr val="E2E8F0"/>
-            </a:solidFill>
-          </a:ln>
-        </p:spPr>
-        <p:style>
-          <a:lnRef idx="1">
-            <a:schemeClr val="accent1"/>
-          </a:lnRef>
-          <a:fillRef idx="3">
-            <a:schemeClr val="accent1"/>
-          </a:fillRef>
-          <a:effectRef idx="2">
-            <a:schemeClr val="accent1"/>
-          </a:effectRef>
-          <a:fontRef idx="minor">
-            <a:schemeClr val="lt1"/>
-          </a:fontRef>
-        </p:style>
-        <p:txBody>
-          <a:bodyPr rtlCol="0" anchor="ctr"/>
-          <a:lstStyle/>
-          <a:p>
-            <a:pPr algn="ctr"/>
-          </a:p>
-        </p:txBody>
-      </p:sp>
-      <p:sp>
-        <p:nvSpPr>
-          <p:cNvPr id="5" name="Rounded Rectangle 4"/>
-          <p:cNvSpPr/>
-          <p:nvPr/>
-        </p:nvSpPr>
-        <p:spPr>
-          <a:xfrm>
-            <a:off x="731520" y="1645920"/>
-            <a:ext cx="73152" cy="2194560"/>
-          </a:xfrm>
-          <a:prstGeom prst="roundRect">
-            <a:avLst/>
-          </a:prstGeom>
-          <a:solidFill>
-            <a:srgbClr val="0071E3"/>
-          </a:solidFill>
-          <a:ln>
-            <a:noFill/>
-          </a:ln>
-        </p:spPr>
-        <p:style>
-          <a:lnRef idx="1">
-            <a:schemeClr val="accent1"/>
-          </a:lnRef>
-          <a:fillRef idx="3">
-            <a:schemeClr val="accent1"/>
-          </a:fillRef>
-          <a:effectRef idx="2">
-            <a:schemeClr val="accent1"/>
-          </a:effectRef>
-          <a:fontRef idx="minor">
-            <a:schemeClr val="lt1"/>
-          </a:fontRef>
-        </p:style>
-        <p:txBody>
-          <a:bodyPr rtlCol="0" anchor="ctr"/>
-          <a:lstStyle/>
-          <a:p>
-            <a:pPr algn="ctr"/>
-          </a:p>
-        </p:txBody>
-      </p:sp>
-      <p:sp>
-        <p:nvSpPr>
-          <p:cNvPr id="6" name="TextBox 5"/>
-          <p:cNvSpPr txBox="1"/>
-          <p:nvPr/>
-        </p:nvSpPr>
-        <p:spPr>
-          <a:xfrm>
-            <a:off x="960120" y="1828800"/>
-            <a:ext cx="3063240" cy="1920240"/>
+        </p:nvPicPr>
+        <p:blipFill>
+          <a:blip r:embed="rId2"/>
+          <a:stretch>
+            <a:fillRect/>
+          </a:stretch>
+        </p:blipFill>
+        <p:spPr>
+          <a:xfrm>
+            <a:off x="731520" y="1554480"/>
+            <a:ext cx="10725912" cy="4892040"/>
           </a:xfrm>
           <a:prstGeom prst="rect">
             <a:avLst/>
           </a:prstGeom>
-          <a:noFill/>
-        </p:spPr>
-        <p:txBody>
-          <a:bodyPr wrap="square">
-            <a:spAutoFit/>
-          </a:bodyPr>
-          <a:lstStyle/>
-          <a:p>
-            <a:pPr>
-              <a:spcAft>
-                <a:spcPts val="600"/>
-              </a:spcAft>
-              <a:defRPr sz="1300" b="1">
-                <a:solidFill>
-                  <a:srgbClr val="0F172A"/>
-                </a:solidFill>
-              </a:defRPr>
-            </a:pPr>
-            <a:r>
-              <a:t>users &amp; members (1 : 1)</a:t>
-            </a:r>
-          </a:p>
-          <a:p>
-            <a:pPr>
-              <a:spcAft>
-                <a:spcPts val="800"/>
-              </a:spcAft>
-              <a:defRPr sz="1000">
-                <a:solidFill>
-                  <a:srgbClr val="64748B"/>
-                </a:solidFill>
-              </a:defRPr>
-            </a:pPr>
-            <a:r>
-              <a:t>users (id, email, password_hash, role) ───&lt; members (id, user_id, member_number, max_loans, status)</a:t>
-            </a:r>
-          </a:p>
-          <a:p>
-            <a:pPr>
-              <a:defRPr sz="900" b="1">
-                <a:solidFill>
-                  <a:srgbClr val="0071E3"/>
-                </a:solidFill>
-              </a:defRPr>
-            </a:pPr>
-            <a:r>
-              <a:t>Constraint: Foreign Key: user_id -&gt; users(id) ON DELETE CASCADE</a:t>
-            </a:r>
-          </a:p>
-        </p:txBody>
-      </p:sp>
-      <p:sp>
-        <p:nvSpPr>
-          <p:cNvPr id="7" name="Rounded Rectangle 6"/>
-          <p:cNvSpPr/>
-          <p:nvPr/>
-        </p:nvSpPr>
-        <p:spPr>
-          <a:xfrm>
-            <a:off x="4389120" y="1645920"/>
-            <a:ext cx="3429000" cy="2194560"/>
-          </a:xfrm>
-          <a:prstGeom prst="roundRect">
-            <a:avLst/>
-          </a:prstGeom>
-          <a:solidFill>
-            <a:srgbClr val="FFFFFF"/>
-          </a:solidFill>
-          <a:ln w="12700">
-            <a:solidFill>
-              <a:srgbClr val="E2E8F0"/>
-            </a:solidFill>
-          </a:ln>
-        </p:spPr>
-        <p:style>
-          <a:lnRef idx="1">
-            <a:schemeClr val="accent1"/>
-          </a:lnRef>
-          <a:fillRef idx="3">
-            <a:schemeClr val="accent1"/>
-          </a:fillRef>
-          <a:effectRef idx="2">
-            <a:schemeClr val="accent1"/>
-          </a:effectRef>
-          <a:fontRef idx="minor">
-            <a:schemeClr val="lt1"/>
-          </a:fontRef>
-        </p:style>
-        <p:txBody>
-          <a:bodyPr rtlCol="0" anchor="ctr"/>
-          <a:lstStyle/>
-          <a:p>
-            <a:pPr algn="ctr"/>
-          </a:p>
-        </p:txBody>
-      </p:sp>
-      <p:sp>
-        <p:nvSpPr>
-          <p:cNvPr id="8" name="Rounded Rectangle 7"/>
-          <p:cNvSpPr/>
-          <p:nvPr/>
-        </p:nvSpPr>
-        <p:spPr>
-          <a:xfrm>
-            <a:off x="4389120" y="1645920"/>
-            <a:ext cx="73152" cy="2194560"/>
-          </a:xfrm>
-          <a:prstGeom prst="roundRect">
-            <a:avLst/>
-          </a:prstGeom>
-          <a:solidFill>
-            <a:srgbClr val="4F46E5"/>
-          </a:solidFill>
-          <a:ln>
-            <a:noFill/>
-          </a:ln>
-        </p:spPr>
-        <p:style>
-          <a:lnRef idx="1">
-            <a:schemeClr val="accent1"/>
-          </a:lnRef>
-          <a:fillRef idx="3">
-            <a:schemeClr val="accent1"/>
-          </a:fillRef>
-          <a:effectRef idx="2">
-            <a:schemeClr val="accent1"/>
-          </a:effectRef>
-          <a:fontRef idx="minor">
-            <a:schemeClr val="lt1"/>
-          </a:fontRef>
-        </p:style>
-        <p:txBody>
-          <a:bodyPr rtlCol="0" anchor="ctr"/>
-          <a:lstStyle/>
-          <a:p>
-            <a:pPr algn="ctr"/>
-          </a:p>
-        </p:txBody>
-      </p:sp>
-      <p:sp>
-        <p:nvSpPr>
-          <p:cNvPr id="9" name="TextBox 8"/>
-          <p:cNvSpPr txBox="1"/>
-          <p:nvPr/>
-        </p:nvSpPr>
-        <p:spPr>
-          <a:xfrm>
-            <a:off x="4617720" y="1828800"/>
-            <a:ext cx="3063240" cy="1920240"/>
-          </a:xfrm>
-          <a:prstGeom prst="rect">
-            <a:avLst/>
-          </a:prstGeom>
-          <a:noFill/>
-        </p:spPr>
-        <p:txBody>
-          <a:bodyPr wrap="square">
-            <a:spAutoFit/>
-          </a:bodyPr>
-          <a:lstStyle/>
-          <a:p>
-            <a:pPr>
-              <a:spcAft>
-                <a:spcPts val="600"/>
-              </a:spcAft>
-              <a:defRPr sz="1300" b="1">
-                <a:solidFill>
-                  <a:srgbClr val="0F172A"/>
-                </a:solidFill>
-              </a:defRPr>
-            </a:pPr>
-            <a:r>
-              <a:t>books &amp; categories (N : 1)</a:t>
-            </a:r>
-          </a:p>
-          <a:p>
-            <a:pPr>
-              <a:spcAft>
-                <a:spcPts val="800"/>
-              </a:spcAft>
-              <a:defRPr sz="1000">
-                <a:solidFill>
-                  <a:srgbClr val="64748B"/>
-                </a:solidFill>
-              </a:defRPr>
-            </a:pPr>
-            <a:r>
-              <a:t>categories (id, name) ───&lt; books (id, isbn, title, category_id, cover_image_url, pdf_url, reader_url)</a:t>
-            </a:r>
-          </a:p>
-          <a:p>
-            <a:pPr>
-              <a:defRPr sz="900" b="1">
-                <a:solidFill>
-                  <a:srgbClr val="4F46E5"/>
-                </a:solidFill>
-              </a:defRPr>
-            </a:pPr>
-            <a:r>
-              <a:t>Constraint: Foreign Key: category_id -&gt; categories(id) ON DELETE SET NULL</a:t>
-            </a:r>
-          </a:p>
-        </p:txBody>
-      </p:sp>
-      <p:sp>
-        <p:nvSpPr>
-          <p:cNvPr id="10" name="Rounded Rectangle 9"/>
-          <p:cNvSpPr/>
-          <p:nvPr/>
-        </p:nvSpPr>
-        <p:spPr>
-          <a:xfrm>
-            <a:off x="8046720" y="1645920"/>
-            <a:ext cx="3429000" cy="2194560"/>
-          </a:xfrm>
-          <a:prstGeom prst="roundRect">
-            <a:avLst/>
-          </a:prstGeom>
-          <a:solidFill>
-            <a:srgbClr val="FFFFFF"/>
-          </a:solidFill>
-          <a:ln w="12700">
-            <a:solidFill>
-              <a:srgbClr val="E2E8F0"/>
-            </a:solidFill>
-          </a:ln>
-        </p:spPr>
-        <p:style>
-          <a:lnRef idx="1">
-            <a:schemeClr val="accent1"/>
-          </a:lnRef>
-          <a:fillRef idx="3">
-            <a:schemeClr val="accent1"/>
-          </a:fillRef>
-          <a:effectRef idx="2">
-            <a:schemeClr val="accent1"/>
-          </a:effectRef>
-          <a:fontRef idx="minor">
-            <a:schemeClr val="lt1"/>
-          </a:fontRef>
-        </p:style>
-        <p:txBody>
-          <a:bodyPr rtlCol="0" anchor="ctr"/>
-          <a:lstStyle/>
-          <a:p>
-            <a:pPr algn="ctr"/>
-          </a:p>
-        </p:txBody>
-      </p:sp>
-      <p:sp>
-        <p:nvSpPr>
-          <p:cNvPr id="11" name="Rounded Rectangle 10"/>
-          <p:cNvSpPr/>
-          <p:nvPr/>
-        </p:nvSpPr>
-        <p:spPr>
-          <a:xfrm>
-            <a:off x="8046720" y="1645920"/>
-            <a:ext cx="73152" cy="2194560"/>
-          </a:xfrm>
-          <a:prstGeom prst="roundRect">
-            <a:avLst/>
-          </a:prstGeom>
-          <a:solidFill>
-            <a:srgbClr val="9D4EDD"/>
-          </a:solidFill>
-          <a:ln>
-            <a:noFill/>
-          </a:ln>
-        </p:spPr>
-        <p:style>
-          <a:lnRef idx="1">
-            <a:schemeClr val="accent1"/>
-          </a:lnRef>
-          <a:fillRef idx="3">
-            <a:schemeClr val="accent1"/>
-          </a:fillRef>
-          <a:effectRef idx="2">
-            <a:schemeClr val="accent1"/>
-          </a:effectRef>
-          <a:fontRef idx="minor">
-            <a:schemeClr val="lt1"/>
-          </a:fontRef>
-        </p:style>
-        <p:txBody>
-          <a:bodyPr rtlCol="0" anchor="ctr"/>
-          <a:lstStyle/>
-          <a:p>
-            <a:pPr algn="ctr"/>
-          </a:p>
-        </p:txBody>
-      </p:sp>
-      <p:sp>
-        <p:nvSpPr>
-          <p:cNvPr id="12" name="TextBox 11"/>
-          <p:cNvSpPr txBox="1"/>
-          <p:nvPr/>
-        </p:nvSpPr>
-        <p:spPr>
-          <a:xfrm>
-            <a:off x="8275320" y="1828800"/>
-            <a:ext cx="3063240" cy="1920240"/>
-          </a:xfrm>
-          <a:prstGeom prst="rect">
-            <a:avLst/>
-          </a:prstGeom>
-          <a:noFill/>
-        </p:spPr>
-        <p:txBody>
-          <a:bodyPr wrap="square">
-            <a:spAutoFit/>
-          </a:bodyPr>
-          <a:lstStyle/>
-          <a:p>
-            <a:pPr>
-              <a:spcAft>
-                <a:spcPts val="600"/>
-              </a:spcAft>
-              <a:defRPr sz="1300" b="1">
-                <a:solidFill>
-                  <a:srgbClr val="0F172A"/>
-                </a:solidFill>
-              </a:defRPr>
-            </a:pPr>
-            <a:r>
-              <a:t>books &amp; authors (M : N Junction)</a:t>
-            </a:r>
-          </a:p>
-          <a:p>
-            <a:pPr>
-              <a:spcAft>
-                <a:spcPts val="800"/>
-              </a:spcAft>
-              <a:defRPr sz="1000">
-                <a:solidFill>
-                  <a:srgbClr val="64748B"/>
-                </a:solidFill>
-              </a:defRPr>
-            </a:pPr>
-            <a:r>
-              <a:t>books ───&lt; book_authors (book_id, author_id) &gt;─── authors (id, name)</a:t>
-            </a:r>
-          </a:p>
-          <a:p>
-            <a:pPr>
-              <a:defRPr sz="900" b="1">
-                <a:solidFill>
-                  <a:srgbClr val="9D4EDD"/>
-                </a:solidFill>
-              </a:defRPr>
-            </a:pPr>
-            <a:r>
-              <a:t>Constraint: Composite Primary Key: (book_id, author_id) with CASCADE deletes</a:t>
-            </a:r>
-          </a:p>
-        </p:txBody>
-      </p:sp>
-      <p:sp>
-        <p:nvSpPr>
-          <p:cNvPr id="13" name="Rounded Rectangle 12"/>
-          <p:cNvSpPr/>
-          <p:nvPr/>
-        </p:nvSpPr>
-        <p:spPr>
-          <a:xfrm>
-            <a:off x="731520" y="4069080"/>
-            <a:ext cx="3429000" cy="2194560"/>
-          </a:xfrm>
-          <a:prstGeom prst="roundRect">
-            <a:avLst/>
-          </a:prstGeom>
-          <a:solidFill>
-            <a:srgbClr val="FFFFFF"/>
-          </a:solidFill>
-          <a:ln w="12700">
-            <a:solidFill>
-              <a:srgbClr val="E2E8F0"/>
-            </a:solidFill>
-          </a:ln>
-        </p:spPr>
-        <p:style>
-          <a:lnRef idx="1">
-            <a:schemeClr val="accent1"/>
-          </a:lnRef>
-          <a:fillRef idx="3">
-            <a:schemeClr val="accent1"/>
-          </a:fillRef>
-          <a:effectRef idx="2">
-            <a:schemeClr val="accent1"/>
-          </a:effectRef>
-          <a:fontRef idx="minor">
-            <a:schemeClr val="lt1"/>
-          </a:fontRef>
-        </p:style>
-        <p:txBody>
-          <a:bodyPr rtlCol="0" anchor="ctr"/>
-          <a:lstStyle/>
-          <a:p>
-            <a:pPr algn="ctr"/>
-          </a:p>
-        </p:txBody>
-      </p:sp>
-      <p:sp>
-        <p:nvSpPr>
-          <p:cNvPr id="14" name="Rounded Rectangle 13"/>
-          <p:cNvSpPr/>
-          <p:nvPr/>
-        </p:nvSpPr>
-        <p:spPr>
-          <a:xfrm>
-            <a:off x="731520" y="4069080"/>
-            <a:ext cx="73152" cy="2194560"/>
-          </a:xfrm>
-          <a:prstGeom prst="roundRect">
-            <a:avLst/>
-          </a:prstGeom>
-          <a:solidFill>
-            <a:srgbClr val="0071E3"/>
-          </a:solidFill>
-          <a:ln>
-            <a:noFill/>
-          </a:ln>
-        </p:spPr>
-        <p:style>
-          <a:lnRef idx="1">
-            <a:schemeClr val="accent1"/>
-          </a:lnRef>
-          <a:fillRef idx="3">
-            <a:schemeClr val="accent1"/>
-          </a:fillRef>
-          <a:effectRef idx="2">
-            <a:schemeClr val="accent1"/>
-          </a:effectRef>
-          <a:fontRef idx="minor">
-            <a:schemeClr val="lt1"/>
-          </a:fontRef>
-        </p:style>
-        <p:txBody>
-          <a:bodyPr rtlCol="0" anchor="ctr"/>
-          <a:lstStyle/>
-          <a:p>
-            <a:pPr algn="ctr"/>
-          </a:p>
-        </p:txBody>
-      </p:sp>
-      <p:sp>
-        <p:nvSpPr>
-          <p:cNvPr id="15" name="TextBox 14"/>
-          <p:cNvSpPr txBox="1"/>
-          <p:nvPr/>
-        </p:nvSpPr>
-        <p:spPr>
-          <a:xfrm>
-            <a:off x="960120" y="4251960"/>
-            <a:ext cx="3063240" cy="1920240"/>
-          </a:xfrm>
-          <a:prstGeom prst="rect">
-            <a:avLst/>
-          </a:prstGeom>
-          <a:noFill/>
-        </p:spPr>
-        <p:txBody>
-          <a:bodyPr wrap="square">
-            <a:spAutoFit/>
-          </a:bodyPr>
-          <a:lstStyle/>
-          <a:p>
-            <a:pPr>
-              <a:spcAft>
-                <a:spcPts val="600"/>
-              </a:spcAft>
-              <a:defRPr sz="1300" b="1">
-                <a:solidFill>
-                  <a:srgbClr val="0F172A"/>
-                </a:solidFill>
-              </a:defRPr>
-            </a:pPr>
-            <a:r>
-              <a:t>books &amp; copies (1 : N Inventory)</a:t>
-            </a:r>
-          </a:p>
-          <a:p>
-            <a:pPr>
-              <a:spcAft>
-                <a:spcPts val="800"/>
-              </a:spcAft>
-              <a:defRPr sz="1000">
-                <a:solidFill>
-                  <a:srgbClr val="64748B"/>
-                </a:solidFill>
-              </a:defRPr>
-            </a:pPr>
-            <a:r>
-              <a:t>books (id) ───&lt; copies (id, book_id, barcode, status, location)</a:t>
-            </a:r>
-          </a:p>
-          <a:p>
-            <a:pPr>
-              <a:defRPr sz="900" b="1">
-                <a:solidFill>
-                  <a:srgbClr val="0071E3"/>
-                </a:solidFill>
-              </a:defRPr>
-            </a:pPr>
-            <a:r>
-              <a:t>Constraint: copies.barcode UNIQUE • status IN ('available','on_loan','on_hold','lost')</a:t>
-            </a:r>
-          </a:p>
-        </p:txBody>
-      </p:sp>
-      <p:sp>
-        <p:nvSpPr>
-          <p:cNvPr id="16" name="Rounded Rectangle 15"/>
-          <p:cNvSpPr/>
-          <p:nvPr/>
-        </p:nvSpPr>
-        <p:spPr>
-          <a:xfrm>
-            <a:off x="4389120" y="4069080"/>
-            <a:ext cx="3429000" cy="2194560"/>
-          </a:xfrm>
-          <a:prstGeom prst="roundRect">
-            <a:avLst/>
-          </a:prstGeom>
-          <a:solidFill>
-            <a:srgbClr val="FFFFFF"/>
-          </a:solidFill>
-          <a:ln w="12700">
-            <a:solidFill>
-              <a:srgbClr val="E2E8F0"/>
-            </a:solidFill>
-          </a:ln>
-        </p:spPr>
-        <p:style>
-          <a:lnRef idx="1">
-            <a:schemeClr val="accent1"/>
-          </a:lnRef>
-          <a:fillRef idx="3">
-            <a:schemeClr val="accent1"/>
-          </a:fillRef>
-          <a:effectRef idx="2">
-            <a:schemeClr val="accent1"/>
-          </a:effectRef>
-          <a:fontRef idx="minor">
-            <a:schemeClr val="lt1"/>
-          </a:fontRef>
-        </p:style>
-        <p:txBody>
-          <a:bodyPr rtlCol="0" anchor="ctr"/>
-          <a:lstStyle/>
-          <a:p>
-            <a:pPr algn="ctr"/>
-          </a:p>
-        </p:txBody>
-      </p:sp>
-      <p:sp>
-        <p:nvSpPr>
-          <p:cNvPr id="17" name="Rounded Rectangle 16"/>
-          <p:cNvSpPr/>
-          <p:nvPr/>
-        </p:nvSpPr>
-        <p:spPr>
-          <a:xfrm>
-            <a:off x="4389120" y="4069080"/>
-            <a:ext cx="73152" cy="2194560"/>
-          </a:xfrm>
-          <a:prstGeom prst="roundRect">
-            <a:avLst/>
-          </a:prstGeom>
-          <a:solidFill>
-            <a:srgbClr val="4F46E5"/>
-          </a:solidFill>
-          <a:ln>
-            <a:noFill/>
-          </a:ln>
-        </p:spPr>
-        <p:style>
-          <a:lnRef idx="1">
-            <a:schemeClr val="accent1"/>
-          </a:lnRef>
-          <a:fillRef idx="3">
-            <a:schemeClr val="accent1"/>
-          </a:fillRef>
-          <a:effectRef idx="2">
-            <a:schemeClr val="accent1"/>
-          </a:effectRef>
-          <a:fontRef idx="minor">
-            <a:schemeClr val="lt1"/>
-          </a:fontRef>
-        </p:style>
-        <p:txBody>
-          <a:bodyPr rtlCol="0" anchor="ctr"/>
-          <a:lstStyle/>
-          <a:p>
-            <a:pPr algn="ctr"/>
-          </a:p>
-        </p:txBody>
-      </p:sp>
-      <p:sp>
-        <p:nvSpPr>
-          <p:cNvPr id="18" name="TextBox 17"/>
-          <p:cNvSpPr txBox="1"/>
-          <p:nvPr/>
-        </p:nvSpPr>
-        <p:spPr>
-          <a:xfrm>
-            <a:off x="4617720" y="4251960"/>
-            <a:ext cx="3063240" cy="1920240"/>
-          </a:xfrm>
-          <a:prstGeom prst="rect">
-            <a:avLst/>
-          </a:prstGeom>
-          <a:noFill/>
-        </p:spPr>
-        <p:txBody>
-          <a:bodyPr wrap="square">
-            <a:spAutoFit/>
-          </a:bodyPr>
-          <a:lstStyle/>
-          <a:p>
-            <a:pPr>
-              <a:spcAft>
-                <a:spcPts val="600"/>
-              </a:spcAft>
-              <a:defRPr sz="1300" b="1">
-                <a:solidFill>
-                  <a:srgbClr val="0F172A"/>
-                </a:solidFill>
-              </a:defRPr>
-            </a:pPr>
-            <a:r>
-              <a:t>copies, members &amp; loans (Circulation)</a:t>
-            </a:r>
-          </a:p>
-          <a:p>
-            <a:pPr>
-              <a:spcAft>
-                <a:spcPts val="800"/>
-              </a:spcAft>
-              <a:defRPr sz="1000">
-                <a:solidFill>
-                  <a:srgbClr val="64748B"/>
-                </a:solidFill>
-              </a:defRPr>
-            </a:pPr>
-            <a:r>
-              <a:t>copies (id) + members (id) ───&lt; loans (id, copy_id, member_id, due_at, renewal_count, fine_amount)</a:t>
-            </a:r>
-          </a:p>
-          <a:p>
-            <a:pPr>
-              <a:defRPr sz="900" b="1">
-                <a:solidFill>
-                  <a:srgbClr val="4F46E5"/>
-                </a:solidFill>
-              </a:defRPr>
-            </a:pPr>
-            <a:r>
-              <a:t>Constraint: PARTIAL UNIQUE INDEX: unique_active_loan_per_copy WHERE returned_at IS NULL</a:t>
-            </a:r>
-          </a:p>
-        </p:txBody>
-      </p:sp>
-      <p:sp>
-        <p:nvSpPr>
-          <p:cNvPr id="19" name="Rounded Rectangle 18"/>
-          <p:cNvSpPr/>
-          <p:nvPr/>
-        </p:nvSpPr>
-        <p:spPr>
-          <a:xfrm>
-            <a:off x="8046720" y="4069080"/>
-            <a:ext cx="3429000" cy="2194560"/>
-          </a:xfrm>
-          <a:prstGeom prst="roundRect">
-            <a:avLst/>
-          </a:prstGeom>
-          <a:solidFill>
-            <a:srgbClr val="FFFFFF"/>
-          </a:solidFill>
-          <a:ln w="12700">
-            <a:solidFill>
-              <a:srgbClr val="E2E8F0"/>
-            </a:solidFill>
-          </a:ln>
-        </p:spPr>
-        <p:style>
-          <a:lnRef idx="1">
-            <a:schemeClr val="accent1"/>
-          </a:lnRef>
-          <a:fillRef idx="3">
-            <a:schemeClr val="accent1"/>
-          </a:fillRef>
-          <a:effectRef idx="2">
-            <a:schemeClr val="accent1"/>
-          </a:effectRef>
-          <a:fontRef idx="minor">
-            <a:schemeClr val="lt1"/>
-          </a:fontRef>
-        </p:style>
-        <p:txBody>
-          <a:bodyPr rtlCol="0" anchor="ctr"/>
-          <a:lstStyle/>
-          <a:p>
-            <a:pPr algn="ctr"/>
-          </a:p>
-        </p:txBody>
-      </p:sp>
-      <p:sp>
-        <p:nvSpPr>
-          <p:cNvPr id="20" name="Rounded Rectangle 19"/>
-          <p:cNvSpPr/>
-          <p:nvPr/>
-        </p:nvSpPr>
-        <p:spPr>
-          <a:xfrm>
-            <a:off x="8046720" y="4069080"/>
-            <a:ext cx="73152" cy="2194560"/>
-          </a:xfrm>
-          <a:prstGeom prst="roundRect">
-            <a:avLst/>
-          </a:prstGeom>
-          <a:solidFill>
-            <a:srgbClr val="9D4EDD"/>
-          </a:solidFill>
-          <a:ln>
-            <a:noFill/>
-          </a:ln>
-        </p:spPr>
-        <p:style>
-          <a:lnRef idx="1">
-            <a:schemeClr val="accent1"/>
-          </a:lnRef>
-          <a:fillRef idx="3">
-            <a:schemeClr val="accent1"/>
-          </a:fillRef>
-          <a:effectRef idx="2">
-            <a:schemeClr val="accent1"/>
-          </a:effectRef>
-          <a:fontRef idx="minor">
-            <a:schemeClr val="lt1"/>
-          </a:fontRef>
-        </p:style>
-        <p:txBody>
-          <a:bodyPr rtlCol="0" anchor="ctr"/>
-          <a:lstStyle/>
-          <a:p>
-            <a:pPr algn="ctr"/>
-          </a:p>
-        </p:txBody>
-      </p:sp>
-      <p:sp>
-        <p:nvSpPr>
-          <p:cNvPr id="21" name="TextBox 20"/>
-          <p:cNvSpPr txBox="1"/>
-          <p:nvPr/>
-        </p:nvSpPr>
-        <p:spPr>
-          <a:xfrm>
-            <a:off x="8275320" y="4251960"/>
-            <a:ext cx="3063240" cy="1920240"/>
-          </a:xfrm>
-          <a:prstGeom prst="rect">
-            <a:avLst/>
-          </a:prstGeom>
-          <a:noFill/>
-        </p:spPr>
-        <p:txBody>
-          <a:bodyPr wrap="square">
-            <a:spAutoFit/>
-          </a:bodyPr>
-          <a:lstStyle/>
-          <a:p>
-            <a:pPr>
-              <a:spcAft>
-                <a:spcPts val="600"/>
-              </a:spcAft>
-              <a:defRPr sz="1300" b="1">
-                <a:solidFill>
-                  <a:srgbClr val="0F172A"/>
-                </a:solidFill>
-              </a:defRPr>
-            </a:pPr>
-            <a:r>
-              <a:t>holds &amp; audit_logs (Queues &amp; Ledgers)</a:t>
-            </a:r>
-          </a:p>
-          <a:p>
-            <a:pPr>
-              <a:spcAft>
-                <a:spcPts val="800"/>
-              </a:spcAft>
-              <a:defRPr sz="1000">
-                <a:solidFill>
-                  <a:srgbClr val="64748B"/>
-                </a:solidFill>
-              </a:defRPr>
-            </a:pPr>
-            <a:r>
-              <a:t>holds (book_id, member_id, allocated_copy_id, status) + audit_logs (action, details)</a:t>
-            </a:r>
-          </a:p>
-          <a:p>
-            <a:pPr>
-              <a:defRPr sz="900" b="1">
-                <a:solidFill>
-                  <a:srgbClr val="9D4EDD"/>
-                </a:solidFill>
-              </a:defRPr>
-            </a:pPr>
-            <a:r>
-              <a:t>Constraint: PARTIAL UNIQUE INDEX: unique_active_hold_per_member_book</a:t>
-            </a:r>
-          </a:p>
-        </p:txBody>
-      </p:sp>
+        </p:spPr>
+      </p:pic>
     </p:spTree>
   </p:cSld>
   <p:clrMapOvr>
@@ -5983,6 +4994,14 @@
 <file path=ppt/slides/slide5.xml><?xml version="1.0" encoding="utf-8"?>
 <p:sld xmlns:a="http://schemas.openxmlformats.org/drawingml/2006/main" xmlns:p="http://schemas.openxmlformats.org/presentationml/2006/main" xmlns:r="http://schemas.openxmlformats.org/officeDocument/2006/relationships">
   <p:cSld>
+    <p:bg>
+      <p:bgPr>
+        <a:solidFill>
+          <a:srgbClr val="09090B"/>
+        </a:solidFill>
+        <a:effectLst/>
+      </p:bgPr>
+    </p:bg>
     <p:spTree>
       <p:nvGrpSpPr>
         <p:cNvPr id="1" name=""/>
@@ -5992,23 +5011,95 @@
       <p:grpSpPr/>
       <p:sp>
         <p:nvSpPr>
-          <p:cNvPr id="2" name="Rectangle 1"/>
+          <p:cNvPr id="2" name="TextBox 1"/>
+          <p:cNvSpPr txBox="1"/>
+          <p:nvPr/>
+        </p:nvSpPr>
+        <p:spPr>
+          <a:xfrm>
+            <a:off x="731520" y="502920"/>
+            <a:ext cx="10698480" cy="365760"/>
+          </a:xfrm>
+          <a:prstGeom prst="rect">
+            <a:avLst/>
+          </a:prstGeom>
+          <a:noFill/>
+        </p:spPr>
+        <p:txBody>
+          <a:bodyPr wrap="square">
+            <a:spAutoFit/>
+          </a:bodyPr>
+          <a:lstStyle/>
+          <a:p>
+            <a:pPr>
+              <a:defRPr sz="1100" b="1">
+                <a:solidFill>
+                  <a:srgbClr val="0071E3"/>
+                </a:solidFill>
+              </a:defRPr>
+            </a:pPr>
+            <a:r>
+              <a:t>WORKFLOW IMPLEMENTATION • TRANSACTION 1</a:t>
+            </a:r>
+          </a:p>
+        </p:txBody>
+      </p:sp>
+      <p:sp>
+        <p:nvSpPr>
+          <p:cNvPr id="3" name="TextBox 2"/>
+          <p:cNvSpPr txBox="1"/>
+          <p:nvPr/>
+        </p:nvSpPr>
+        <p:spPr>
+          <a:xfrm>
+            <a:off x="731520" y="777240"/>
+            <a:ext cx="10698480" cy="731520"/>
+          </a:xfrm>
+          <a:prstGeom prst="rect">
+            <a:avLst/>
+          </a:prstGeom>
+          <a:noFill/>
+        </p:spPr>
+        <p:txBody>
+          <a:bodyPr wrap="square">
+            <a:spAutoFit/>
+          </a:bodyPr>
+          <a:lstStyle/>
+          <a:p>
+            <a:pPr>
+              <a:defRPr sz="2600" b="1">
+                <a:solidFill>
+                  <a:srgbClr val="FAFAFA"/>
+                </a:solidFill>
+              </a:defRPr>
+            </a:pPr>
+            <a:r>
+              <a:t>Journey 1: Transactional Checkout Workflow</a:t>
+            </a:r>
+          </a:p>
+        </p:txBody>
+      </p:sp>
+      <p:sp>
+        <p:nvSpPr>
+          <p:cNvPr id="4" name="Rounded Rectangle 3"/>
           <p:cNvSpPr/>
           <p:nvPr/>
         </p:nvSpPr>
         <p:spPr>
           <a:xfrm>
-            <a:off x="0" y="0"/>
-            <a:ext cx="12191695" cy="6858000"/>
-          </a:xfrm>
-          <a:prstGeom prst="rect">
+            <a:off x="731520" y="1645920"/>
+            <a:ext cx="2542032" cy="4663440"/>
+          </a:xfrm>
+          <a:prstGeom prst="roundRect">
             <a:avLst/>
           </a:prstGeom>
           <a:solidFill>
-            <a:srgbClr val="F8FAFC"/>
+            <a:srgbClr val="141418"/>
           </a:solidFill>
-          <a:ln>
-            <a:noFill/>
+          <a:ln w="15240">
+            <a:solidFill>
+              <a:srgbClr val="27272E"/>
+            </a:solidFill>
           </a:ln>
         </p:spPr>
         <p:style>
@@ -6035,14 +5126,14 @@
       </p:sp>
       <p:sp>
         <p:nvSpPr>
-          <p:cNvPr id="3" name="TextBox 2"/>
+          <p:cNvPr id="5" name="TextBox 4"/>
           <p:cNvSpPr txBox="1"/>
           <p:nvPr/>
         </p:nvSpPr>
         <p:spPr>
           <a:xfrm>
-            <a:off x="731520" y="457200"/>
-            <a:ext cx="10698480" cy="1005840"/>
+            <a:off x="960120" y="1920240"/>
+            <a:ext cx="2084832" cy="4206240"/>
           </a:xfrm>
           <a:prstGeom prst="rect">
             <a:avLst/>
@@ -6057,52 +5148,70 @@
           <a:p>
             <a:pPr>
               <a:spcAft>
-                <a:spcPts val="400"/>
-              </a:spcAft>
-              <a:defRPr sz="1100" b="1">
+                <a:spcPts val="1200"/>
+              </a:spcAft>
+              <a:defRPr sz="3000" b="1">
                 <a:solidFill>
                   <a:srgbClr val="0071E3"/>
                 </a:solidFill>
               </a:defRPr>
             </a:pPr>
             <a:r>
-              <a:t>WORKFLOW IMPLEMENTATION • TRANSACTION 1</a:t>
-            </a:r>
-          </a:p>
-          <a:p>
-            <a:pPr>
-              <a:defRPr sz="2500" b="1">
-                <a:solidFill>
-                  <a:srgbClr val="0F172A"/>
-                </a:solidFill>
-              </a:defRPr>
-            </a:pPr>
-            <a:r>
-              <a:t>Journey 1: Transactional Checkout Workflow</a:t>
-            </a:r>
-          </a:p>
-        </p:txBody>
-      </p:sp>
-      <p:sp>
-        <p:nvSpPr>
-          <p:cNvPr id="4" name="Rounded Rectangle 3"/>
+              <a:t>01</a:t>
+            </a:r>
+          </a:p>
+          <a:p>
+            <a:pPr>
+              <a:spcAft>
+                <a:spcPts val="1200"/>
+              </a:spcAft>
+              <a:defRPr sz="1500" b="1">
+                <a:solidFill>
+                  <a:srgbClr val="FAFAFA"/>
+                </a:solidFill>
+              </a:defRPr>
+            </a:pPr>
+            <a:r>
+              <a:t>Input &amp; Validation</a:t>
+            </a:r>
+          </a:p>
+          <a:p>
+            <a:pPr>
+              <a:lnSpc>
+                <a:spcPct val="120000"/>
+              </a:lnSpc>
+              <a:defRPr sz="1150">
+                <a:solidFill>
+                  <a:srgbClr val="A1A1AA"/>
+                </a:solidFill>
+              </a:defRPr>
+            </a:pPr>
+            <a:r>
+              <a:t>Librarian scans Member Card (MEM-XXXXX) and Item Barcode. Zod validates payload format.</a:t>
+            </a:r>
+          </a:p>
+        </p:txBody>
+      </p:sp>
+      <p:sp>
+        <p:nvSpPr>
+          <p:cNvPr id="6" name="Rounded Rectangle 5"/>
           <p:cNvSpPr/>
           <p:nvPr/>
         </p:nvSpPr>
         <p:spPr>
           <a:xfrm>
-            <a:off x="731520" y="1645920"/>
+            <a:off x="3456432" y="1645920"/>
             <a:ext cx="2542032" cy="4663440"/>
           </a:xfrm>
           <a:prstGeom prst="roundRect">
             <a:avLst/>
           </a:prstGeom>
           <a:solidFill>
-            <a:srgbClr val="FFFFFF"/>
+            <a:srgbClr val="141418"/>
           </a:solidFill>
-          <a:ln w="12700">
+          <a:ln w="15240">
             <a:solidFill>
-              <a:srgbClr val="E2E8F0"/>
+              <a:srgbClr val="27272E"/>
             </a:solidFill>
           </a:ln>
         </p:spPr>
@@ -6130,13 +5239,13 @@
       </p:sp>
       <p:sp>
         <p:nvSpPr>
-          <p:cNvPr id="5" name="TextBox 4"/>
+          <p:cNvPr id="7" name="TextBox 6"/>
           <p:cNvSpPr txBox="1"/>
           <p:nvPr/>
         </p:nvSpPr>
         <p:spPr>
           <a:xfrm>
-            <a:off x="960120" y="1920240"/>
+            <a:off x="3685032" y="1920240"/>
             <a:ext cx="2084832" cy="4206240"/>
           </a:xfrm>
           <a:prstGeom prst="rect">
@@ -6156,12 +5265,12 @@
               </a:spcAft>
               <a:defRPr sz="3000" b="1">
                 <a:solidFill>
-                  <a:srgbClr val="0071E3"/>
-                </a:solidFill>
-              </a:defRPr>
-            </a:pPr>
-            <a:r>
-              <a:t>01</a:t>
+                  <a:srgbClr val="38BDF8"/>
+                </a:solidFill>
+              </a:defRPr>
+            </a:pPr>
+            <a:r>
+              <a:t>02</a:t>
             </a:r>
           </a:p>
           <a:p>
@@ -6171,12 +5280,12 @@
               </a:spcAft>
               <a:defRPr sz="1500" b="1">
                 <a:solidFill>
-                  <a:srgbClr val="0F172A"/>
-                </a:solidFill>
-              </a:defRPr>
-            </a:pPr>
-            <a:r>
-              <a:t>Input &amp; Validation</a:t>
+                  <a:srgbClr val="FAFAFA"/>
+                </a:solidFill>
+              </a:defRPr>
+            </a:pPr>
+            <a:r>
+              <a:t>Account &amp; Quota Check</a:t>
             </a:r>
           </a:p>
           <a:p>
@@ -6186,36 +5295,36 @@
               </a:lnSpc>
               <a:defRPr sz="1150">
                 <a:solidFill>
-                  <a:srgbClr val="64748B"/>
-                </a:solidFill>
-              </a:defRPr>
-            </a:pPr>
-            <a:r>
-              <a:t>Librarian enters Member ID/Barcode and Copy Barcode. Zod validates payload format.</a:t>
-            </a:r>
-          </a:p>
-        </p:txBody>
-      </p:sp>
-      <p:sp>
-        <p:nvSpPr>
-          <p:cNvPr id="6" name="Rounded Rectangle 5"/>
+                  <a:srgbClr val="A1A1AA"/>
+                </a:solidFill>
+              </a:defRPr>
+            </a:pPr>
+            <a:r>
+              <a:t>Verifies member is 'active' with zero unpaid fines and active loans &lt; max_loans (quota limit).</a:t>
+            </a:r>
+          </a:p>
+        </p:txBody>
+      </p:sp>
+      <p:sp>
+        <p:nvSpPr>
+          <p:cNvPr id="8" name="Rounded Rectangle 7"/>
           <p:cNvSpPr/>
           <p:nvPr/>
         </p:nvSpPr>
         <p:spPr>
           <a:xfrm>
-            <a:off x="3456432" y="1645920"/>
+            <a:off x="6181344" y="1645920"/>
             <a:ext cx="2542032" cy="4663440"/>
           </a:xfrm>
           <a:prstGeom prst="roundRect">
             <a:avLst/>
           </a:prstGeom>
           <a:solidFill>
-            <a:srgbClr val="FFFFFF"/>
+            <a:srgbClr val="141418"/>
           </a:solidFill>
-          <a:ln w="12700">
+          <a:ln w="15240">
             <a:solidFill>
-              <a:srgbClr val="E2E8F0"/>
+              <a:srgbClr val="27272E"/>
             </a:solidFill>
           </a:ln>
         </p:spPr>
@@ -6243,13 +5352,13 @@
       </p:sp>
       <p:sp>
         <p:nvSpPr>
-          <p:cNvPr id="7" name="TextBox 6"/>
+          <p:cNvPr id="9" name="TextBox 8"/>
           <p:cNvSpPr txBox="1"/>
           <p:nvPr/>
         </p:nvSpPr>
         <p:spPr>
           <a:xfrm>
-            <a:off x="3685032" y="1920240"/>
+            <a:off x="6409944" y="1920240"/>
             <a:ext cx="2084832" cy="4206240"/>
           </a:xfrm>
           <a:prstGeom prst="rect">
@@ -6269,12 +5378,12 @@
               </a:spcAft>
               <a:defRPr sz="3000" b="1">
                 <a:solidFill>
-                  <a:srgbClr val="4F46E5"/>
-                </a:solidFill>
-              </a:defRPr>
-            </a:pPr>
-            <a:r>
-              <a:t>02</a:t>
+                  <a:srgbClr val="0071E3"/>
+                </a:solidFill>
+              </a:defRPr>
+            </a:pPr>
+            <a:r>
+              <a:t>03</a:t>
             </a:r>
           </a:p>
           <a:p>
@@ -6284,12 +5393,12 @@
               </a:spcAft>
               <a:defRPr sz="1500" b="1">
                 <a:solidFill>
-                  <a:srgbClr val="0F172A"/>
-                </a:solidFill>
-              </a:defRPr>
-            </a:pPr>
-            <a:r>
-              <a:t>Member Status Verification</a:t>
+                  <a:srgbClr val="FAFAFA"/>
+                </a:solidFill>
+              </a:defRPr>
+            </a:pPr>
+            <a:r>
+              <a:t>Copy Availability Check</a:t>
             </a:r>
           </a:p>
           <a:p>
@@ -6299,36 +5408,36 @@
               </a:lnSpc>
               <a:defRPr sz="1150">
                 <a:solidFill>
-                  <a:srgbClr val="64748B"/>
-                </a:solidFill>
-              </a:defRPr>
-            </a:pPr>
-            <a:r>
-              <a:t>Verifies member.status == 'active'. Suspended or expired members immediately rejected.</a:t>
-            </a:r>
-          </a:p>
-        </p:txBody>
-      </p:sp>
-      <p:sp>
-        <p:nvSpPr>
-          <p:cNvPr id="8" name="Rounded Rectangle 7"/>
+                  <a:srgbClr val="A1A1AA"/>
+                </a:solidFill>
+              </a:defRPr>
+            </a:pPr>
+            <a:r>
+              <a:t>Ensures copy status is 'available' or allocated to this specific borrower via reservation hold.</a:t>
+            </a:r>
+          </a:p>
+        </p:txBody>
+      </p:sp>
+      <p:sp>
+        <p:nvSpPr>
+          <p:cNvPr id="10" name="Rounded Rectangle 9"/>
           <p:cNvSpPr/>
           <p:nvPr/>
         </p:nvSpPr>
         <p:spPr>
           <a:xfrm>
-            <a:off x="6181344" y="1645920"/>
+            <a:off x="8906256" y="1645920"/>
             <a:ext cx="2542032" cy="4663440"/>
           </a:xfrm>
           <a:prstGeom prst="roundRect">
             <a:avLst/>
           </a:prstGeom>
           <a:solidFill>
-            <a:srgbClr val="FFFFFF"/>
+            <a:srgbClr val="141418"/>
           </a:solidFill>
-          <a:ln w="12700">
+          <a:ln w="15240">
             <a:solidFill>
-              <a:srgbClr val="E2E8F0"/>
+              <a:srgbClr val="27272E"/>
             </a:solidFill>
           </a:ln>
         </p:spPr>
@@ -6356,13 +5465,13 @@
       </p:sp>
       <p:sp>
         <p:nvSpPr>
-          <p:cNvPr id="9" name="TextBox 8"/>
+          <p:cNvPr id="11" name="TextBox 10"/>
           <p:cNvSpPr txBox="1"/>
           <p:nvPr/>
         </p:nvSpPr>
         <p:spPr>
           <a:xfrm>
-            <a:off x="6409944" y="1920240"/>
+            <a:off x="9134856" y="1920240"/>
             <a:ext cx="2084832" cy="4206240"/>
           </a:xfrm>
           <a:prstGeom prst="rect">
@@ -6382,12 +5491,12 @@
               </a:spcAft>
               <a:defRPr sz="3000" b="1">
                 <a:solidFill>
-                  <a:srgbClr val="4F46E5"/>
-                </a:solidFill>
-              </a:defRPr>
-            </a:pPr>
-            <a:r>
-              <a:t>03</a:t>
+                  <a:srgbClr val="38BDF8"/>
+                </a:solidFill>
+              </a:defRPr>
+            </a:pPr>
+            <a:r>
+              <a:t>04</a:t>
             </a:r>
           </a:p>
           <a:p>
@@ -6397,12 +5506,12 @@
               </a:spcAft>
               <a:defRPr sz="1500" b="1">
                 <a:solidFill>
-                  <a:srgbClr val="0F172A"/>
-                </a:solidFill>
-              </a:defRPr>
-            </a:pPr>
-            <a:r>
-              <a:t>Borrowing Limit Enforcement</a:t>
+                  <a:srgbClr val="FAFAFA"/>
+                </a:solidFill>
+              </a:defRPr>
+            </a:pPr>
+            <a:r>
+              <a:t>Atomic Lock &amp; Commit</a:t>
             </a:r>
           </a:p>
           <a:p>
@@ -6412,125 +5521,12 @@
               </a:lnSpc>
               <a:defRPr sz="1150">
                 <a:solidFill>
-                  <a:srgbClr val="64748B"/>
-                </a:solidFill>
-              </a:defRPr>
-            </a:pPr>
-            <a:r>
-              <a:t>Counts active loans. If active &gt;= max_loans (e.g. 5), transaction aborts with informative error.</a:t>
-            </a:r>
-          </a:p>
-        </p:txBody>
-      </p:sp>
-      <p:sp>
-        <p:nvSpPr>
-          <p:cNvPr id="10" name="Rounded Rectangle 9"/>
-          <p:cNvSpPr/>
-          <p:nvPr/>
-        </p:nvSpPr>
-        <p:spPr>
-          <a:xfrm>
-            <a:off x="8906256" y="1645920"/>
-            <a:ext cx="2542032" cy="4663440"/>
-          </a:xfrm>
-          <a:prstGeom prst="roundRect">
-            <a:avLst/>
-          </a:prstGeom>
-          <a:solidFill>
-            <a:srgbClr val="FFFFFF"/>
-          </a:solidFill>
-          <a:ln w="12700">
-            <a:solidFill>
-              <a:srgbClr val="E2E8F0"/>
-            </a:solidFill>
-          </a:ln>
-        </p:spPr>
-        <p:style>
-          <a:lnRef idx="1">
-            <a:schemeClr val="accent1"/>
-          </a:lnRef>
-          <a:fillRef idx="3">
-            <a:schemeClr val="accent1"/>
-          </a:fillRef>
-          <a:effectRef idx="2">
-            <a:schemeClr val="accent1"/>
-          </a:effectRef>
-          <a:fontRef idx="minor">
-            <a:schemeClr val="lt1"/>
-          </a:fontRef>
-        </p:style>
-        <p:txBody>
-          <a:bodyPr rtlCol="0" anchor="ctr"/>
-          <a:lstStyle/>
-          <a:p>
-            <a:pPr algn="ctr"/>
-          </a:p>
-        </p:txBody>
-      </p:sp>
-      <p:sp>
-        <p:nvSpPr>
-          <p:cNvPr id="11" name="TextBox 10"/>
-          <p:cNvSpPr txBox="1"/>
-          <p:nvPr/>
-        </p:nvSpPr>
-        <p:spPr>
-          <a:xfrm>
-            <a:off x="9134856" y="1920240"/>
-            <a:ext cx="2084832" cy="4206240"/>
-          </a:xfrm>
-          <a:prstGeom prst="rect">
-            <a:avLst/>
-          </a:prstGeom>
-          <a:noFill/>
-        </p:spPr>
-        <p:txBody>
-          <a:bodyPr wrap="square">
-            <a:spAutoFit/>
-          </a:bodyPr>
-          <a:lstStyle/>
-          <a:p>
-            <a:pPr>
-              <a:spcAft>
-                <a:spcPts val="1200"/>
-              </a:spcAft>
-              <a:defRPr sz="3000" b="1">
-                <a:solidFill>
-                  <a:srgbClr val="10B981"/>
-                </a:solidFill>
-              </a:defRPr>
-            </a:pPr>
-            <a:r>
-              <a:t>04</a:t>
-            </a:r>
-          </a:p>
-          <a:p>
-            <a:pPr>
-              <a:spcAft>
-                <a:spcPts val="1200"/>
-              </a:spcAft>
-              <a:defRPr sz="1500" b="1">
-                <a:solidFill>
-                  <a:srgbClr val="0F172A"/>
-                </a:solidFill>
-              </a:defRPr>
-            </a:pPr>
-            <a:r>
-              <a:t>Atomic Lock &amp; Commit</a:t>
-            </a:r>
-          </a:p>
-          <a:p>
-            <a:pPr>
-              <a:lnSpc>
-                <a:spcPct val="120000"/>
-              </a:lnSpc>
-              <a:defRPr sz="1150">
-                <a:solidFill>
-                  <a:srgbClr val="64748B"/>
-                </a:solidFill>
-              </a:defRPr>
-            </a:pPr>
-            <a:r>
-              <a:t>Inserts record into loans, transitions copy status to 'on_loan', fulfills holds in one atomic db.transaction().</a:t>
+                  <a:srgbClr val="A1A1AA"/>
+                </a:solidFill>
+              </a:defRPr>
+            </a:pPr>
+            <a:r>
+              <a:t>Inserts record into loans, updates copy status to 'on_loan', fulfills holds in one atomic db.transaction().</a:t>
             </a:r>
           </a:p>
         </p:txBody>
@@ -6546,6 +5542,14 @@
 <file path=ppt/slides/slide6.xml><?xml version="1.0" encoding="utf-8"?>
 <p:sld xmlns:a="http://schemas.openxmlformats.org/drawingml/2006/main" xmlns:p="http://schemas.openxmlformats.org/presentationml/2006/main" xmlns:r="http://schemas.openxmlformats.org/officeDocument/2006/relationships">
   <p:cSld>
+    <p:bg>
+      <p:bgPr>
+        <a:solidFill>
+          <a:srgbClr val="09090B"/>
+        </a:solidFill>
+        <a:effectLst/>
+      </p:bgPr>
+    </p:bg>
     <p:spTree>
       <p:nvGrpSpPr>
         <p:cNvPr id="1" name=""/>
@@ -6555,23 +5559,95 @@
       <p:grpSpPr/>
       <p:sp>
         <p:nvSpPr>
-          <p:cNvPr id="2" name="Rectangle 1"/>
+          <p:cNvPr id="2" name="TextBox 1"/>
+          <p:cNvSpPr txBox="1"/>
+          <p:nvPr/>
+        </p:nvSpPr>
+        <p:spPr>
+          <a:xfrm>
+            <a:off x="731520" y="502920"/>
+            <a:ext cx="10698480" cy="365760"/>
+          </a:xfrm>
+          <a:prstGeom prst="rect">
+            <a:avLst/>
+          </a:prstGeom>
+          <a:noFill/>
+        </p:spPr>
+        <p:txBody>
+          <a:bodyPr wrap="square">
+            <a:spAutoFit/>
+          </a:bodyPr>
+          <a:lstStyle/>
+          <a:p>
+            <a:pPr>
+              <a:defRPr sz="1100" b="1">
+                <a:solidFill>
+                  <a:srgbClr val="0071E3"/>
+                </a:solidFill>
+              </a:defRPr>
+            </a:pPr>
+            <a:r>
+              <a:t>WORKFLOW IMPLEMENTATION • TRANSACTION 2</a:t>
+            </a:r>
+          </a:p>
+        </p:txBody>
+      </p:sp>
+      <p:sp>
+        <p:nvSpPr>
+          <p:cNvPr id="3" name="TextBox 2"/>
+          <p:cNvSpPr txBox="1"/>
+          <p:nvPr/>
+        </p:nvSpPr>
+        <p:spPr>
+          <a:xfrm>
+            <a:off x="731520" y="777240"/>
+            <a:ext cx="10698480" cy="731520"/>
+          </a:xfrm>
+          <a:prstGeom prst="rect">
+            <a:avLst/>
+          </a:prstGeom>
+          <a:noFill/>
+        </p:spPr>
+        <p:txBody>
+          <a:bodyPr wrap="square">
+            <a:spAutoFit/>
+          </a:bodyPr>
+          <a:lstStyle/>
+          <a:p>
+            <a:pPr>
+              <a:defRPr sz="2600" b="1">
+                <a:solidFill>
+                  <a:srgbClr val="FAFAFA"/>
+                </a:solidFill>
+              </a:defRPr>
+            </a:pPr>
+            <a:r>
+              <a:t>Journey 2: Return Workflow &amp; Hold Queue Promotion</a:t>
+            </a:r>
+          </a:p>
+        </p:txBody>
+      </p:sp>
+      <p:sp>
+        <p:nvSpPr>
+          <p:cNvPr id="4" name="Rounded Rectangle 3"/>
           <p:cNvSpPr/>
           <p:nvPr/>
         </p:nvSpPr>
         <p:spPr>
           <a:xfrm>
-            <a:off x="0" y="0"/>
-            <a:ext cx="12191695" cy="6858000"/>
-          </a:xfrm>
-          <a:prstGeom prst="rect">
+            <a:off x="731520" y="1645920"/>
+            <a:ext cx="2542032" cy="4663440"/>
+          </a:xfrm>
+          <a:prstGeom prst="roundRect">
             <a:avLst/>
           </a:prstGeom>
           <a:solidFill>
-            <a:srgbClr val="F8FAFC"/>
+            <a:srgbClr val="141418"/>
           </a:solidFill>
-          <a:ln>
-            <a:noFill/>
+          <a:ln w="15240">
+            <a:solidFill>
+              <a:srgbClr val="27272E"/>
+            </a:solidFill>
           </a:ln>
         </p:spPr>
         <p:style>
@@ -6598,14 +5674,14 @@
       </p:sp>
       <p:sp>
         <p:nvSpPr>
-          <p:cNvPr id="3" name="TextBox 2"/>
+          <p:cNvPr id="5" name="TextBox 4"/>
           <p:cNvSpPr txBox="1"/>
           <p:nvPr/>
         </p:nvSpPr>
         <p:spPr>
           <a:xfrm>
-            <a:off x="731520" y="457200"/>
-            <a:ext cx="10698480" cy="1005840"/>
+            <a:off x="960120" y="1920240"/>
+            <a:ext cx="2084832" cy="4206240"/>
           </a:xfrm>
           <a:prstGeom prst="rect">
             <a:avLst/>
@@ -6620,52 +5696,70 @@
           <a:p>
             <a:pPr>
               <a:spcAft>
-                <a:spcPts val="400"/>
-              </a:spcAft>
-              <a:defRPr sz="1100" b="1">
+                <a:spcPts val="1200"/>
+              </a:spcAft>
+              <a:defRPr sz="3000" b="1">
                 <a:solidFill>
                   <a:srgbClr val="0071E3"/>
                 </a:solidFill>
               </a:defRPr>
             </a:pPr>
             <a:r>
-              <a:t>WORKFLOW IMPLEMENTATION • TRANSACTION 2</a:t>
-            </a:r>
-          </a:p>
-          <a:p>
-            <a:pPr>
-              <a:defRPr sz="2500" b="1">
-                <a:solidFill>
-                  <a:srgbClr val="0F172A"/>
-                </a:solidFill>
-              </a:defRPr>
-            </a:pPr>
-            <a:r>
-              <a:t>Journey 2: Return Workflow &amp; Hold Queue Promotion</a:t>
-            </a:r>
-          </a:p>
-        </p:txBody>
-      </p:sp>
-      <p:sp>
-        <p:nvSpPr>
-          <p:cNvPr id="4" name="Rounded Rectangle 3"/>
+              <a:t>01</a:t>
+            </a:r>
+          </a:p>
+          <a:p>
+            <a:pPr>
+              <a:spcAft>
+                <a:spcPts val="1200"/>
+              </a:spcAft>
+              <a:defRPr sz="1500" b="1">
+                <a:solidFill>
+                  <a:srgbClr val="FAFAFA"/>
+                </a:solidFill>
+              </a:defRPr>
+            </a:pPr>
+            <a:r>
+              <a:t>Barcode Check-In</a:t>
+            </a:r>
+          </a:p>
+          <a:p>
+            <a:pPr>
+              <a:lnSpc>
+                <a:spcPct val="120000"/>
+              </a:lnSpc>
+              <a:defRPr sz="1150">
+                <a:solidFill>
+                  <a:srgbClr val="A1A1AA"/>
+                </a:solidFill>
+              </a:defRPr>
+            </a:pPr>
+            <a:r>
+              <a:t>Librarian scans returned copy barcode. System locates active loan record where returned_at IS NULL.</a:t>
+            </a:r>
+          </a:p>
+        </p:txBody>
+      </p:sp>
+      <p:sp>
+        <p:nvSpPr>
+          <p:cNvPr id="6" name="Rounded Rectangle 5"/>
           <p:cNvSpPr/>
           <p:nvPr/>
         </p:nvSpPr>
         <p:spPr>
           <a:xfrm>
-            <a:off x="731520" y="1645920"/>
+            <a:off x="3456432" y="1645920"/>
             <a:ext cx="2542032" cy="4663440"/>
           </a:xfrm>
           <a:prstGeom prst="roundRect">
             <a:avLst/>
           </a:prstGeom>
           <a:solidFill>
-            <a:srgbClr val="FFFFFF"/>
+            <a:srgbClr val="141418"/>
           </a:solidFill>
-          <a:ln w="12700">
+          <a:ln w="15240">
             <a:solidFill>
-              <a:srgbClr val="E2E8F0"/>
+              <a:srgbClr val="27272E"/>
             </a:solidFill>
           </a:ln>
         </p:spPr>
@@ -6693,13 +5787,13 @@
       </p:sp>
       <p:sp>
         <p:nvSpPr>
-          <p:cNvPr id="5" name="TextBox 4"/>
+          <p:cNvPr id="7" name="TextBox 6"/>
           <p:cNvSpPr txBox="1"/>
           <p:nvPr/>
         </p:nvSpPr>
         <p:spPr>
           <a:xfrm>
-            <a:off x="960120" y="1920240"/>
+            <a:off x="3685032" y="1920240"/>
             <a:ext cx="2084832" cy="4206240"/>
           </a:xfrm>
           <a:prstGeom prst="rect">
@@ -6719,12 +5813,12 @@
               </a:spcAft>
               <a:defRPr sz="3000" b="1">
                 <a:solidFill>
-                  <a:srgbClr val="0071E3"/>
-                </a:solidFill>
-              </a:defRPr>
-            </a:pPr>
-            <a:r>
-              <a:t>01</a:t>
+                  <a:srgbClr val="38BDF8"/>
+                </a:solidFill>
+              </a:defRPr>
+            </a:pPr>
+            <a:r>
+              <a:t>02</a:t>
             </a:r>
           </a:p>
           <a:p>
@@ -6734,12 +5828,12 @@
               </a:spcAft>
               <a:defRPr sz="1500" b="1">
                 <a:solidFill>
-                  <a:srgbClr val="0F172A"/>
-                </a:solidFill>
-              </a:defRPr>
-            </a:pPr>
-            <a:r>
-              <a:t>Barcode Check-In</a:t>
+                  <a:srgbClr val="FAFAFA"/>
+                </a:solidFill>
+              </a:defRPr>
+            </a:pPr>
+            <a:r>
+              <a:t>Dynamic Overdue Calculation</a:t>
             </a:r>
           </a:p>
           <a:p>
@@ -6749,36 +5843,36 @@
               </a:lnSpc>
               <a:defRPr sz="1150">
                 <a:solidFill>
-                  <a:srgbClr val="64748B"/>
-                </a:solidFill>
-              </a:defRPr>
-            </a:pPr>
-            <a:r>
-              <a:t>Librarian scans returned copy barcode. System locates active loan record where returned_at IS NULL.</a:t>
-            </a:r>
-          </a:p>
-        </p:txBody>
-      </p:sp>
-      <p:sp>
-        <p:nvSpPr>
-          <p:cNvPr id="6" name="Rounded Rectangle 5"/>
+                  <a:srgbClr val="A1A1AA"/>
+                </a:solidFill>
+              </a:defRPr>
+            </a:pPr>
+            <a:r>
+              <a:t>Calculates (returned_at - due_at). If positive, computes fine ($1.00/day) and persists fine_amount.</a:t>
+            </a:r>
+          </a:p>
+        </p:txBody>
+      </p:sp>
+      <p:sp>
+        <p:nvSpPr>
+          <p:cNvPr id="8" name="Rounded Rectangle 7"/>
           <p:cNvSpPr/>
           <p:nvPr/>
         </p:nvSpPr>
         <p:spPr>
           <a:xfrm>
-            <a:off x="3456432" y="1645920"/>
+            <a:off x="6181344" y="1645920"/>
             <a:ext cx="2542032" cy="4663440"/>
           </a:xfrm>
           <a:prstGeom prst="roundRect">
             <a:avLst/>
           </a:prstGeom>
           <a:solidFill>
-            <a:srgbClr val="FFFFFF"/>
+            <a:srgbClr val="141418"/>
           </a:solidFill>
-          <a:ln w="12700">
+          <a:ln w="15240">
             <a:solidFill>
-              <a:srgbClr val="E2E8F0"/>
+              <a:srgbClr val="27272E"/>
             </a:solidFill>
           </a:ln>
         </p:spPr>
@@ -6806,13 +5900,13 @@
       </p:sp>
       <p:sp>
         <p:nvSpPr>
-          <p:cNvPr id="7" name="TextBox 6"/>
+          <p:cNvPr id="9" name="TextBox 8"/>
           <p:cNvSpPr txBox="1"/>
           <p:nvPr/>
         </p:nvSpPr>
         <p:spPr>
           <a:xfrm>
-            <a:off x="3685032" y="1920240"/>
+            <a:off x="6409944" y="1920240"/>
             <a:ext cx="2084832" cy="4206240"/>
           </a:xfrm>
           <a:prstGeom prst="rect">
@@ -6832,12 +5926,12 @@
               </a:spcAft>
               <a:defRPr sz="3000" b="1">
                 <a:solidFill>
-                  <a:srgbClr val="4F46E5"/>
-                </a:solidFill>
-              </a:defRPr>
-            </a:pPr>
-            <a:r>
-              <a:t>02</a:t>
+                  <a:srgbClr val="0071E3"/>
+                </a:solidFill>
+              </a:defRPr>
+            </a:pPr>
+            <a:r>
+              <a:t>03</a:t>
             </a:r>
           </a:p>
           <a:p>
@@ -6847,12 +5941,12 @@
               </a:spcAft>
               <a:defRPr sz="1500" b="1">
                 <a:solidFill>
-                  <a:srgbClr val="0F172A"/>
-                </a:solidFill>
-              </a:defRPr>
-            </a:pPr>
-            <a:r>
-              <a:t>Dynamic Overdue Calculation</a:t>
+                  <a:srgbClr val="FAFAFA"/>
+                </a:solidFill>
+              </a:defRPr>
+            </a:pPr>
+            <a:r>
+              <a:t>Reservation Queue Check</a:t>
             </a:r>
           </a:p>
           <a:p>
@@ -6862,36 +5956,36 @@
               </a:lnSpc>
               <a:defRPr sz="1150">
                 <a:solidFill>
-                  <a:srgbClr val="64748B"/>
-                </a:solidFill>
-              </a:defRPr>
-            </a:pPr>
-            <a:r>
-              <a:t>Calculates (returned_at - due_at). If positive, computes fine ($1.00/day) and persists fine_amount.</a:t>
-            </a:r>
-          </a:p>
-        </p:txBody>
-      </p:sp>
-      <p:sp>
-        <p:nvSpPr>
-          <p:cNvPr id="8" name="Rounded Rectangle 7"/>
+                  <a:srgbClr val="A1A1AA"/>
+                </a:solidFill>
+              </a:defRPr>
+            </a:pPr>
+            <a:r>
+              <a:t>Queries holds for next 'waiting' member ordered by placed_at ASC (First-Come, First-Served).</a:t>
+            </a:r>
+          </a:p>
+        </p:txBody>
+      </p:sp>
+      <p:sp>
+        <p:nvSpPr>
+          <p:cNvPr id="10" name="Rounded Rectangle 9"/>
           <p:cNvSpPr/>
           <p:nvPr/>
         </p:nvSpPr>
         <p:spPr>
           <a:xfrm>
-            <a:off x="6181344" y="1645920"/>
+            <a:off x="8906256" y="1645920"/>
             <a:ext cx="2542032" cy="4663440"/>
           </a:xfrm>
           <a:prstGeom prst="roundRect">
             <a:avLst/>
           </a:prstGeom>
           <a:solidFill>
-            <a:srgbClr val="FFFFFF"/>
+            <a:srgbClr val="141418"/>
           </a:solidFill>
-          <a:ln w="12700">
+          <a:ln w="15240">
             <a:solidFill>
-              <a:srgbClr val="E2E8F0"/>
+              <a:srgbClr val="27272E"/>
             </a:solidFill>
           </a:ln>
         </p:spPr>
@@ -6919,13 +6013,13 @@
       </p:sp>
       <p:sp>
         <p:nvSpPr>
-          <p:cNvPr id="9" name="TextBox 8"/>
+          <p:cNvPr id="11" name="TextBox 10"/>
           <p:cNvSpPr txBox="1"/>
           <p:nvPr/>
         </p:nvSpPr>
         <p:spPr>
           <a:xfrm>
-            <a:off x="6409944" y="1920240"/>
+            <a:off x="9134856" y="1920240"/>
             <a:ext cx="2084832" cy="4206240"/>
           </a:xfrm>
           <a:prstGeom prst="rect">
@@ -6945,12 +6039,12 @@
               </a:spcAft>
               <a:defRPr sz="3000" b="1">
                 <a:solidFill>
-                  <a:srgbClr val="4F46E5"/>
-                </a:solidFill>
-              </a:defRPr>
-            </a:pPr>
-            <a:r>
-              <a:t>03</a:t>
+                  <a:srgbClr val="38BDF8"/>
+                </a:solidFill>
+              </a:defRPr>
+            </a:pPr>
+            <a:r>
+              <a:t>04</a:t>
             </a:r>
           </a:p>
           <a:p>
@@ -6960,12 +6054,12 @@
               </a:spcAft>
               <a:defRPr sz="1500" b="1">
                 <a:solidFill>
-                  <a:srgbClr val="0F172A"/>
-                </a:solidFill>
-              </a:defRPr>
-            </a:pPr>
-            <a:r>
-              <a:t>Reservation Queue Check</a:t>
+                  <a:srgbClr val="FAFAFA"/>
+                </a:solidFill>
+              </a:defRPr>
+            </a:pPr>
+            <a:r>
+              <a:t>State Transition</a:t>
             </a:r>
           </a:p>
           <a:p>
@@ -6975,120 +6069,7 @@
               </a:lnSpc>
               <a:defRPr sz="1150">
                 <a:solidFill>
-                  <a:srgbClr val="64748B"/>
-                </a:solidFill>
-              </a:defRPr>
-            </a:pPr>
-            <a:r>
-              <a:t>Queries holds for next 'waiting' member ordered by placed_at ASC (First-Come, First-Served).</a:t>
-            </a:r>
-          </a:p>
-        </p:txBody>
-      </p:sp>
-      <p:sp>
-        <p:nvSpPr>
-          <p:cNvPr id="10" name="Rounded Rectangle 9"/>
-          <p:cNvSpPr/>
-          <p:nvPr/>
-        </p:nvSpPr>
-        <p:spPr>
-          <a:xfrm>
-            <a:off x="8906256" y="1645920"/>
-            <a:ext cx="2542032" cy="4663440"/>
-          </a:xfrm>
-          <a:prstGeom prst="roundRect">
-            <a:avLst/>
-          </a:prstGeom>
-          <a:solidFill>
-            <a:srgbClr val="FFFFFF"/>
-          </a:solidFill>
-          <a:ln w="12700">
-            <a:solidFill>
-              <a:srgbClr val="E2E8F0"/>
-            </a:solidFill>
-          </a:ln>
-        </p:spPr>
-        <p:style>
-          <a:lnRef idx="1">
-            <a:schemeClr val="accent1"/>
-          </a:lnRef>
-          <a:fillRef idx="3">
-            <a:schemeClr val="accent1"/>
-          </a:fillRef>
-          <a:effectRef idx="2">
-            <a:schemeClr val="accent1"/>
-          </a:effectRef>
-          <a:fontRef idx="minor">
-            <a:schemeClr val="lt1"/>
-          </a:fontRef>
-        </p:style>
-        <p:txBody>
-          <a:bodyPr rtlCol="0" anchor="ctr"/>
-          <a:lstStyle/>
-          <a:p>
-            <a:pPr algn="ctr"/>
-          </a:p>
-        </p:txBody>
-      </p:sp>
-      <p:sp>
-        <p:nvSpPr>
-          <p:cNvPr id="11" name="TextBox 10"/>
-          <p:cNvSpPr txBox="1"/>
-          <p:nvPr/>
-        </p:nvSpPr>
-        <p:spPr>
-          <a:xfrm>
-            <a:off x="9134856" y="1920240"/>
-            <a:ext cx="2084832" cy="4206240"/>
-          </a:xfrm>
-          <a:prstGeom prst="rect">
-            <a:avLst/>
-          </a:prstGeom>
-          <a:noFill/>
-        </p:spPr>
-        <p:txBody>
-          <a:bodyPr wrap="square">
-            <a:spAutoFit/>
-          </a:bodyPr>
-          <a:lstStyle/>
-          <a:p>
-            <a:pPr>
-              <a:spcAft>
-                <a:spcPts val="1200"/>
-              </a:spcAft>
-              <a:defRPr sz="3000" b="1">
-                <a:solidFill>
-                  <a:srgbClr val="10B981"/>
-                </a:solidFill>
-              </a:defRPr>
-            </a:pPr>
-            <a:r>
-              <a:t>04</a:t>
-            </a:r>
-          </a:p>
-          <a:p>
-            <a:pPr>
-              <a:spcAft>
-                <a:spcPts val="1200"/>
-              </a:spcAft>
-              <a:defRPr sz="1500" b="1">
-                <a:solidFill>
-                  <a:srgbClr val="0F172A"/>
-                </a:solidFill>
-              </a:defRPr>
-            </a:pPr>
-            <a:r>
-              <a:t>State Transition</a:t>
-            </a:r>
-          </a:p>
-          <a:p>
-            <a:pPr>
-              <a:lnSpc>
-                <a:spcPct val="120000"/>
-              </a:lnSpc>
-              <a:defRPr sz="1150">
-                <a:solidFill>
-                  <a:srgbClr val="64748B"/>
+                  <a:srgbClr val="A1A1AA"/>
                 </a:solidFill>
               </a:defRPr>
             </a:pPr>
@@ -7109,6 +6090,14 @@
 <file path=ppt/slides/slide7.xml><?xml version="1.0" encoding="utf-8"?>
 <p:sld xmlns:a="http://schemas.openxmlformats.org/drawingml/2006/main" xmlns:p="http://schemas.openxmlformats.org/presentationml/2006/main" xmlns:r="http://schemas.openxmlformats.org/officeDocument/2006/relationships">
   <p:cSld>
+    <p:bg>
+      <p:bgPr>
+        <a:solidFill>
+          <a:srgbClr val="09090B"/>
+        </a:solidFill>
+        <a:effectLst/>
+      </p:bgPr>
+    </p:bg>
     <p:spTree>
       <p:nvGrpSpPr>
         <p:cNvPr id="1" name=""/>
@@ -7118,44 +6107,36 @@
       <p:grpSpPr/>
       <p:sp>
         <p:nvSpPr>
-          <p:cNvPr id="2" name="Rectangle 1"/>
-          <p:cNvSpPr/>
+          <p:cNvPr id="2" name="TextBox 1"/>
+          <p:cNvSpPr txBox="1"/>
           <p:nvPr/>
         </p:nvSpPr>
         <p:spPr>
           <a:xfrm>
-            <a:off x="0" y="0"/>
-            <a:ext cx="12191695" cy="6858000"/>
+            <a:off x="731520" y="502920"/>
+            <a:ext cx="10698480" cy="365760"/>
           </a:xfrm>
           <a:prstGeom prst="rect">
             <a:avLst/>
           </a:prstGeom>
-          <a:solidFill>
-            <a:srgbClr val="F8FAFC"/>
-          </a:solidFill>
-          <a:ln>
-            <a:noFill/>
-          </a:ln>
-        </p:spPr>
-        <p:style>
-          <a:lnRef idx="1">
-            <a:schemeClr val="accent1"/>
-          </a:lnRef>
-          <a:fillRef idx="3">
-            <a:schemeClr val="accent1"/>
-          </a:fillRef>
-          <a:effectRef idx="2">
-            <a:schemeClr val="accent1"/>
-          </a:effectRef>
-          <a:fontRef idx="minor">
-            <a:schemeClr val="lt1"/>
-          </a:fontRef>
-        </p:style>
-        <p:txBody>
-          <a:bodyPr rtlCol="0" anchor="ctr"/>
-          <a:lstStyle/>
-          <a:p>
-            <a:pPr algn="ctr"/>
+          <a:noFill/>
+        </p:spPr>
+        <p:txBody>
+          <a:bodyPr wrap="square">
+            <a:spAutoFit/>
+          </a:bodyPr>
+          <a:lstStyle/>
+          <a:p>
+            <a:pPr>
+              <a:defRPr sz="1100" b="1">
+                <a:solidFill>
+                  <a:srgbClr val="0071E3"/>
+                </a:solidFill>
+              </a:defRPr>
+            </a:pPr>
+            <a:r>
+              <a:t>LENDING EXTENSION &amp; APPROVAL GOVERNANCE</a:t>
+            </a:r>
           </a:p>
         </p:txBody>
       </p:sp>
@@ -7167,8 +6148,8 @@
         </p:nvSpPr>
         <p:spPr>
           <a:xfrm>
-            <a:off x="731520" y="457200"/>
-            <a:ext cx="10698480" cy="1005840"/>
+            <a:off x="731520" y="777240"/>
+            <a:ext cx="10698480" cy="731520"/>
           </a:xfrm>
           <a:prstGeom prst="rect">
             <a:avLst/>
@@ -7182,29 +6163,14 @@
           <a:lstStyle/>
           <a:p>
             <a:pPr>
-              <a:spcAft>
-                <a:spcPts val="400"/>
-              </a:spcAft>
-              <a:defRPr sz="1100" b="1">
-                <a:solidFill>
-                  <a:srgbClr val="0071E3"/>
-                </a:solidFill>
-              </a:defRPr>
-            </a:pPr>
-            <a:r>
-              <a:t>ADVANCED EXTENSIONS • RENEWALS &amp; REAPERS</a:t>
-            </a:r>
-          </a:p>
-          <a:p>
-            <a:pPr>
-              <a:defRPr sz="2500" b="1">
-                <a:solidFill>
-                  <a:srgbClr val="0F172A"/>
-                </a:solidFill>
-              </a:defRPr>
-            </a:pPr>
-            <a:r>
-              <a:t>Self-Service Loan Renewal &amp; Automated Hold Reaper</a:t>
+              <a:defRPr sz="2600" b="1">
+                <a:solidFill>
+                  <a:srgbClr val="FAFAFA"/>
+                </a:solidFill>
+              </a:defRPr>
+            </a:pPr>
+            <a:r>
+              <a:t>Loan Extension Application &amp; Librarian Approval Governance</a:t>
             </a:r>
           </a:p>
         </p:txBody>
@@ -7224,11 +6190,11 @@
             <a:avLst/>
           </a:prstGeom>
           <a:solidFill>
-            <a:srgbClr val="FFFFFF"/>
+            <a:srgbClr val="141418"/>
           </a:solidFill>
-          <a:ln w="12700">
+          <a:ln w="15240">
             <a:solidFill>
-              <a:srgbClr val="E2E8F0"/>
+              <a:srgbClr val="27272E"/>
             </a:solidFill>
           </a:ln>
         </p:spPr>
@@ -7325,12 +6291,12 @@
               </a:spcAft>
               <a:defRPr sz="1700" b="1">
                 <a:solidFill>
-                  <a:srgbClr val="0F172A"/>
-                </a:solidFill>
-              </a:defRPr>
-            </a:pPr>
-            <a:r>
-              <a:t>Operational Self-Service Renewal (+7 Days)</a:t>
+                  <a:srgbClr val="FAFAFA"/>
+                </a:solidFill>
+              </a:defRPr>
+            </a:pPr>
+            <a:r>
+              <a:t>Student / Member Application Flow</a:t>
             </a:r>
           </a:p>
           <a:p>
@@ -7340,12 +6306,12 @@
               </a:spcAft>
               <a:defRPr sz="1200">
                 <a:solidFill>
-                  <a:srgbClr val="64748B"/>
-                </a:solidFill>
-              </a:defRPr>
-            </a:pPr>
-            <a:r>
-              <a:t>• Endpoint &amp; UI: POST /api/loans/:id/renew with optimistic real-time UI state updates.</a:t>
+                  <a:srgbClr val="A1A1AA"/>
+                </a:solidFill>
+              </a:defRPr>
+            </a:pPr>
+            <a:r>
+              <a:t>• Self-Service Application: Members click 'Apply for Extension' in My Account rather than automated renewal.</a:t>
             </a:r>
           </a:p>
           <a:p>
@@ -7355,12 +6321,12 @@
               </a:spcAft>
               <a:defRPr sz="1200">
                 <a:solidFill>
-                  <a:srgbClr val="64748B"/>
-                </a:solidFill>
-              </a:defRPr>
-            </a:pPr>
-            <a:r>
-              <a:t>• Rule 1: Overdue Prohibition — If current date &gt; due_at, renewal is blocked with late fee warning.</a:t>
+                  <a:srgbClr val="A1A1AA"/>
+                </a:solidFill>
+              </a:defRPr>
+            </a:pPr>
+            <a:r>
+              <a:t>• Academic Justification: Member selects requested window (+7, +14, +21 days) and submits reasoning (exams, thesis).</a:t>
             </a:r>
           </a:p>
           <a:p>
@@ -7370,12 +6336,12 @@
               </a:spcAft>
               <a:defRPr sz="1200">
                 <a:solidFill>
-                  <a:srgbClr val="64748B"/>
-                </a:solidFill>
-              </a:defRPr>
-            </a:pPr>
-            <a:r>
-              <a:t>• Rule 2: Quota Limit — Maximum 2 renewals permitted per loan record (tracked via renewal_count).</a:t>
+                  <a:srgbClr val="A1A1AA"/>
+                </a:solidFill>
+              </a:defRPr>
+            </a:pPr>
+            <a:r>
+              <a:t>• Instant Dialog Dismissal: Modal auto-dismisses upon submission with reactive UI banner.</a:t>
             </a:r>
           </a:p>
           <a:p>
@@ -7385,12 +6351,12 @@
               </a:spcAft>
               <a:defRPr sz="1200">
                 <a:solidFill>
-                  <a:srgbClr val="64748B"/>
-                </a:solidFill>
-              </a:defRPr>
-            </a:pPr>
-            <a:r>
-              <a:t>• Rule 3: Queue Priority Protection — If other students have placed holds on the book title, renewal is rejected to prevent starvation.</a:t>
+                  <a:srgbClr val="A1A1AA"/>
+                </a:solidFill>
+              </a:defRPr>
+            </a:pPr>
+            <a:r>
+              <a:t>• Live Lifecycle Badging: Dynamic badge changes to 'Under Librarian Review', 'Extension Approved', or 'Extension Rejected' with librarian notes.</a:t>
             </a:r>
           </a:p>
         </p:txBody>
@@ -7410,11 +6376,11 @@
             <a:avLst/>
           </a:prstGeom>
           <a:solidFill>
-            <a:srgbClr val="FFFFFF"/>
+            <a:srgbClr val="141418"/>
           </a:solidFill>
-          <a:ln w="12700">
+          <a:ln w="15240">
             <a:solidFill>
-              <a:srgbClr val="E2E8F0"/>
+              <a:srgbClr val="27272E"/>
             </a:solidFill>
           </a:ln>
         </p:spPr>
@@ -7455,7 +6421,7 @@
             <a:avLst/>
           </a:prstGeom>
           <a:solidFill>
-            <a:srgbClr val="4F46E5"/>
+            <a:srgbClr val="8B5CF6"/>
           </a:solidFill>
           <a:ln>
             <a:noFill/>
@@ -7511,12 +6477,12 @@
               </a:spcAft>
               <a:defRPr sz="1700" b="1">
                 <a:solidFill>
-                  <a:srgbClr val="0F172A"/>
-                </a:solidFill>
-              </a:defRPr>
-            </a:pPr>
-            <a:r>
-              <a:t>Automated Hold Expiration Background Worker</a:t>
+                  <a:srgbClr val="FAFAFA"/>
+                </a:solidFill>
+              </a:defRPr>
+            </a:pPr>
+            <a:r>
+              <a:t>Librarian Approval &amp; Inventory Protection</a:t>
             </a:r>
           </a:p>
           <a:p>
@@ -7526,12 +6492,12 @@
               </a:spcAft>
               <a:defRPr sz="1200">
                 <a:solidFill>
-                  <a:srgbClr val="64748B"/>
-                </a:solidFill>
-              </a:defRPr>
-            </a:pPr>
-            <a:r>
-              <a:t>• Worker Function: reapExpiredHolds() executed every 60 seconds via background timer.</a:t>
+                  <a:srgbClr val="A1A1AA"/>
+                </a:solidFill>
+              </a:defRPr>
+            </a:pPr>
+            <a:r>
+              <a:t>• Librarian Control Desk: Dedicated 'Pending Extension Applications' review queue on librarian dashboard.</a:t>
             </a:r>
           </a:p>
           <a:p>
@@ -7541,12 +6507,12 @@
               </a:spcAft>
               <a:defRPr sz="1200">
                 <a:solidFill>
-                  <a:srgbClr val="64748B"/>
-                </a:solidFill>
-              </a:defRPr>
-            </a:pPr>
-            <a:r>
-              <a:t>• Expiration Detection: Queries holds WHERE status = 'ready_for_pickup' AND datetime('now') &gt; datetime(expires_at).</a:t>
+                  <a:srgbClr val="A1A1AA"/>
+                </a:solidFill>
+              </a:defRPr>
+            </a:pPr>
+            <a:r>
+              <a:t>• Demand &amp; Queue Checks: Librarian inspects borrower history and waiting hold counts before deciding.</a:t>
             </a:r>
           </a:p>
           <a:p>
@@ -7556,12 +6522,12 @@
               </a:spcAft>
               <a:defRPr sz="1200">
                 <a:solidFill>
-                  <a:srgbClr val="64748B"/>
-                </a:solidFill>
-              </a:defRPr>
-            </a:pPr>
-            <a:r>
-              <a:t>• Automatic Re-allocation: Transitions delinquent hold to 'expired' and immediately assigns physical copy to the NEXT student.</a:t>
+                  <a:srgbClr val="A1A1AA"/>
+                </a:solidFill>
+              </a:defRPr>
+            </a:pPr>
+            <a:r>
+              <a:t>• Instant Queue Update: Approving/rejecting immediately removes the card from the pending queue.</a:t>
             </a:r>
           </a:p>
           <a:p>
@@ -7571,12 +6537,12 @@
               </a:spcAft>
               <a:defRPr sz="1200">
                 <a:solidFill>
-                  <a:srgbClr val="64748B"/>
-                </a:solidFill>
-              </a:defRPr>
-            </a:pPr>
-            <a:r>
-              <a:t>• Inventory Fallback: If no other student is waiting, copy status automatically reverts to 'available' on shelf.</a:t>
+                  <a:srgbClr val="A1A1AA"/>
+                </a:solidFill>
+              </a:defRPr>
+            </a:pPr>
+            <a:r>
+              <a:t>• Quota &amp; Overdue Guard: Blocked if item is already overdue or if 2-extension maximum has been reached.</a:t>
             </a:r>
           </a:p>
         </p:txBody>
@@ -7592,6 +6558,14 @@
 <file path=ppt/slides/slide8.xml><?xml version="1.0" encoding="utf-8"?>
 <p:sld xmlns:a="http://schemas.openxmlformats.org/drawingml/2006/main" xmlns:p="http://schemas.openxmlformats.org/presentationml/2006/main" xmlns:r="http://schemas.openxmlformats.org/officeDocument/2006/relationships">
   <p:cSld>
+    <p:bg>
+      <p:bgPr>
+        <a:solidFill>
+          <a:srgbClr val="09090B"/>
+        </a:solidFill>
+        <a:effectLst/>
+      </p:bgPr>
+    </p:bg>
     <p:spTree>
       <p:nvGrpSpPr>
         <p:cNvPr id="1" name=""/>
@@ -7601,44 +6575,36 @@
       <p:grpSpPr/>
       <p:sp>
         <p:nvSpPr>
-          <p:cNvPr id="2" name="Rectangle 1"/>
-          <p:cNvSpPr/>
+          <p:cNvPr id="2" name="TextBox 1"/>
+          <p:cNvSpPr txBox="1"/>
           <p:nvPr/>
         </p:nvSpPr>
         <p:spPr>
           <a:xfrm>
-            <a:off x="0" y="0"/>
-            <a:ext cx="12191695" cy="6858000"/>
+            <a:off x="731520" y="502920"/>
+            <a:ext cx="10698480" cy="365760"/>
           </a:xfrm>
           <a:prstGeom prst="rect">
             <a:avLst/>
           </a:prstGeom>
-          <a:solidFill>
-            <a:srgbClr val="F8FAFC"/>
-          </a:solidFill>
-          <a:ln>
-            <a:noFill/>
-          </a:ln>
-        </p:spPr>
-        <p:style>
-          <a:lnRef idx="1">
-            <a:schemeClr val="accent1"/>
-          </a:lnRef>
-          <a:fillRef idx="3">
-            <a:schemeClr val="accent1"/>
-          </a:fillRef>
-          <a:effectRef idx="2">
-            <a:schemeClr val="accent1"/>
-          </a:effectRef>
-          <a:fontRef idx="minor">
-            <a:schemeClr val="lt1"/>
-          </a:fontRef>
-        </p:style>
-        <p:txBody>
-          <a:bodyPr rtlCol="0" anchor="ctr"/>
-          <a:lstStyle/>
-          <a:p>
-            <a:pPr algn="ctr"/>
+          <a:noFill/>
+        </p:spPr>
+        <p:txBody>
+          <a:bodyPr wrap="square">
+            <a:spAutoFit/>
+          </a:bodyPr>
+          <a:lstStyle/>
+          <a:p>
+            <a:pPr>
+              <a:defRPr sz="1100" b="1">
+                <a:solidFill>
+                  <a:srgbClr val="0071E3"/>
+                </a:solidFill>
+              </a:defRPr>
+            </a:pPr>
+            <a:r>
+              <a:t>ROLE-BASED ACCESS CONTROL (RBAC)</a:t>
+            </a:r>
           </a:p>
         </p:txBody>
       </p:sp>
@@ -7650,8 +6616,8 @@
         </p:nvSpPr>
         <p:spPr>
           <a:xfrm>
-            <a:off x="731520" y="457200"/>
-            <a:ext cx="10698480" cy="1005840"/>
+            <a:off x="731520" y="777240"/>
+            <a:ext cx="10698480" cy="731520"/>
           </a:xfrm>
           <a:prstGeom prst="rect">
             <a:avLst/>
@@ -7665,24 +6631,9 @@
           <a:lstStyle/>
           <a:p>
             <a:pPr>
-              <a:spcAft>
-                <a:spcPts val="400"/>
-              </a:spcAft>
-              <a:defRPr sz="1100" b="1">
-                <a:solidFill>
-                  <a:srgbClr val="0071E3"/>
-                </a:solidFill>
-              </a:defRPr>
-            </a:pPr>
-            <a:r>
-              <a:t>ROLE-BASED ACCESS CONTROL (RBAC)</a:t>
-            </a:r>
-          </a:p>
-          <a:p>
-            <a:pPr>
-              <a:defRPr sz="2500" b="1">
-                <a:solidFill>
-                  <a:srgbClr val="0F172A"/>
+              <a:defRPr sz="2600" b="1">
+                <a:solidFill>
+                  <a:srgbClr val="FAFAFA"/>
                 </a:solidFill>
               </a:defRPr>
             </a:pPr>
@@ -7707,11 +6658,11 @@
             <a:avLst/>
           </a:prstGeom>
           <a:solidFill>
-            <a:srgbClr val="FFFFFF"/>
+            <a:srgbClr val="141418"/>
           </a:solidFill>
-          <a:ln w="12700">
+          <a:ln w="15240">
             <a:solidFill>
-              <a:srgbClr val="E2E8F0"/>
+              <a:srgbClr val="27272E"/>
             </a:solidFill>
           </a:ln>
         </p:spPr>
@@ -7808,7 +6759,7 @@
               </a:spcAft>
               <a:defRPr sz="1500" b="1">
                 <a:solidFill>
-                  <a:srgbClr val="0F172A"/>
+                  <a:srgbClr val="FAFAFA"/>
                 </a:solidFill>
               </a:defRPr>
             </a:pPr>
@@ -7828,7 +6779,7 @@
               </a:defRPr>
             </a:pPr>
             <a:r>
-              <a:t>Self-Service Circulation &amp; Reader</a:t>
+              <a:t>Self-Service Portal &amp; Reservations</a:t>
             </a:r>
           </a:p>
           <a:p>
@@ -7838,7 +6789,7 @@
               </a:spcAft>
               <a:defRPr sz="1100">
                 <a:solidFill>
-                  <a:srgbClr val="64748B"/>
+                  <a:srgbClr val="A1A1AA"/>
                 </a:solidFill>
               </a:defRPr>
             </a:pPr>
@@ -7853,12 +6804,12 @@
               </a:spcAft>
               <a:defRPr sz="1100">
                 <a:solidFill>
-                  <a:srgbClr val="64748B"/>
-                </a:solidFill>
-              </a:defRPr>
-            </a:pPr>
-            <a:r>
-              <a:t>• One-Click Renewal: Operational +7 day loan renewal with instant live due date updates.</a:t>
+                  <a:srgbClr val="A1A1AA"/>
+                </a:solidFill>
+              </a:defRPr>
+            </a:pPr>
+            <a:r>
+              <a:t>• Online Reservation: 'Reserve for Library Pickup' with 3-day hold window on available copies.</a:t>
             </a:r>
           </a:p>
           <a:p>
@@ -7868,12 +6819,12 @@
               </a:spcAft>
               <a:defRPr sz="1100">
                 <a:solidFill>
-                  <a:srgbClr val="64748B"/>
-                </a:solidFill>
-              </a:defRPr>
-            </a:pPr>
-            <a:r>
-              <a:t>• Reservation Management: Place or cancel waiting holds on high-demand titles.</a:t>
+                  <a:srgbClr val="A1A1AA"/>
+                </a:solidFill>
+              </a:defRPr>
+            </a:pPr>
+            <a:r>
+              <a:t>• Extension Applications: Formal loan window prolongation request with live approval feedback.</a:t>
             </a:r>
           </a:p>
           <a:p>
@@ -7883,12 +6834,12 @@
               </a:spcAft>
               <a:defRPr sz="1100">
                 <a:solidFill>
-                  <a:srgbClr val="64748B"/>
-                </a:solidFill>
-              </a:defRPr>
-            </a:pPr>
-            <a:r>
-              <a:t>• Open E-Library: Browse public-domain digital books and open full-screen readers.</a:t>
+                  <a:srgbClr val="A1A1AA"/>
+                </a:solidFill>
+              </a:defRPr>
+            </a:pPr>
+            <a:r>
+              <a:t>• Open E-Library: Browse open-access books and open full-screen e-readers.</a:t>
             </a:r>
           </a:p>
         </p:txBody>
@@ -7908,11 +6859,11 @@
             <a:avLst/>
           </a:prstGeom>
           <a:solidFill>
-            <a:srgbClr val="FFFFFF"/>
+            <a:srgbClr val="141418"/>
           </a:solidFill>
-          <a:ln w="12700">
+          <a:ln w="15240">
             <a:solidFill>
-              <a:srgbClr val="E2E8F0"/>
+              <a:srgbClr val="27272E"/>
             </a:solidFill>
           </a:ln>
         </p:spPr>
@@ -7953,7 +6904,7 @@
             <a:avLst/>
           </a:prstGeom>
           <a:solidFill>
-            <a:srgbClr val="4F46E5"/>
+            <a:srgbClr val="8B5CF6"/>
           </a:solidFill>
           <a:ln>
             <a:noFill/>
@@ -8009,12 +6960,12 @@
               </a:spcAft>
               <a:defRPr sz="1500" b="1">
                 <a:solidFill>
-                  <a:srgbClr val="0F172A"/>
-                </a:solidFill>
-              </a:defRPr>
-            </a:pPr>
-            <a:r>
-              <a:t>Librarian View (Desk Staff)</a:t>
+                  <a:srgbClr val="FAFAFA"/>
+                </a:solidFill>
+              </a:defRPr>
+            </a:pPr>
+            <a:r>
+              <a:t>Librarian View (Staff)</a:t>
             </a:r>
           </a:p>
           <a:p>
@@ -8024,12 +6975,12 @@
               </a:spcAft>
               <a:defRPr sz="1000" b="1">
                 <a:solidFill>
-                  <a:srgbClr val="4F46E5"/>
-                </a:solidFill>
-              </a:defRPr>
-            </a:pPr>
-            <a:r>
-              <a:t>Real-Time Inventory &amp; Circulation</a:t>
+                  <a:srgbClr val="8B5CF6"/>
+                </a:solidFill>
+              </a:defRPr>
+            </a:pPr>
+            <a:r>
+              <a:t>Inventory Health &amp; Circulation Desk</a:t>
             </a:r>
           </a:p>
           <a:p>
@@ -8039,12 +6990,12 @@
               </a:spcAft>
               <a:defRPr sz="1100">
                 <a:solidFill>
-                  <a:srgbClr val="64748B"/>
-                </a:solidFill>
-              </a:defRPr>
-            </a:pPr>
-            <a:r>
-              <a:t>• Librarian Dashboard: Real-time tracking of Copies On Shelf (Available) vs. Currently Borrowed.</a:t>
+                  <a:srgbClr val="A1A1AA"/>
+                </a:solidFill>
+              </a:defRPr>
+            </a:pPr>
+            <a:r>
+              <a:t>• 5 Key Operational Metrics: Total Titles, Shelf Availability %, Active Loans, Ready for Pickup, Extension Requests.</a:t>
             </a:r>
           </a:p>
           <a:p>
@@ -8054,7 +7005,22 @@
               </a:spcAft>
               <a:defRPr sz="1100">
                 <a:solidFill>
-                  <a:srgbClr val="64748B"/>
+                  <a:srgbClr val="A1A1AA"/>
+                </a:solidFill>
+              </a:defRPr>
+            </a:pPr>
+            <a:r>
+              <a:t>• Extension Approval Desk: One-click Approve (+Xd) and Reject interface with student justification view.</a:t>
+            </a:r>
+          </a:p>
+          <a:p>
+            <a:pPr>
+              <a:spcAft>
+                <a:spcPts val="900"/>
+              </a:spcAft>
+              <a:defRPr sz="1100">
+                <a:solidFill>
+                  <a:srgbClr val="A1A1AA"/>
                 </a:solidFill>
               </a:defRPr>
             </a:pPr>
@@ -8069,27 +7035,12 @@
               </a:spcAft>
               <a:defRPr sz="1100">
                 <a:solidFill>
-                  <a:srgbClr val="64748B"/>
-                </a:solidFill>
-              </a:defRPr>
-            </a:pPr>
-            <a:r>
-              <a:t>• Inventory Minting: Add new titles to the catalog and generate unique physical barcodes.</a:t>
-            </a:r>
-          </a:p>
-          <a:p>
-            <a:pPr>
-              <a:spcAft>
-                <a:spcPts val="900"/>
-              </a:spcAft>
-              <a:defRPr sz="1100">
-                <a:solidFill>
-                  <a:srgbClr val="64748B"/>
-                </a:solidFill>
-              </a:defRPr>
-            </a:pPr>
-            <a:r>
-              <a:t>• Catalog Control: Real-time copy breakdown and shelf location inspection.</a:t>
+                  <a:srgbClr val="A1A1AA"/>
+                </a:solidFill>
+              </a:defRPr>
+            </a:pPr>
+            <a:r>
+              <a:t>• ISBN Auto-Scanning: Scan or enter ISBN to auto-fetch catalog metadata from Open Library.</a:t>
             </a:r>
           </a:p>
         </p:txBody>
@@ -8109,11 +7060,11 @@
             <a:avLst/>
           </a:prstGeom>
           <a:solidFill>
-            <a:srgbClr val="FFFFFF"/>
+            <a:srgbClr val="141418"/>
           </a:solidFill>
-          <a:ln w="12700">
+          <a:ln w="15240">
             <a:solidFill>
-              <a:srgbClr val="E2E8F0"/>
+              <a:srgbClr val="27272E"/>
             </a:solidFill>
           </a:ln>
         </p:spPr>
@@ -8210,7 +7161,7 @@
               </a:spcAft>
               <a:defRPr sz="1500" b="1">
                 <a:solidFill>
-                  <a:srgbClr val="0F172A"/>
+                  <a:srgbClr val="FAFAFA"/>
                 </a:solidFill>
               </a:defRPr>
             </a:pPr>
@@ -8240,12 +7191,12 @@
               </a:spcAft>
               <a:defRPr sz="1100">
                 <a:solidFill>
-                  <a:srgbClr val="64748B"/>
-                </a:solidFill>
-              </a:defRPr>
-            </a:pPr>
-            <a:r>
-              <a:t>• Member Account Management: Provision student accounts, assign quotas, suspend/activate.</a:t>
+                  <a:srgbClr val="A1A1AA"/>
+                </a:solidFill>
+              </a:defRPr>
+            </a:pPr>
+            <a:r>
+              <a:t>• Member Roster: Provision student accounts, mint MEM-XXXXX cards, toggle active/suspended.</a:t>
             </a:r>
           </a:p>
           <a:p>
@@ -8255,12 +7206,12 @@
               </a:spcAft>
               <a:defRPr sz="1100">
                 <a:solidFill>
-                  <a:srgbClr val="64748B"/>
-                </a:solidFill>
-              </a:defRPr>
-            </a:pPr>
-            <a:r>
-              <a:t>• Circulation Analytics: Overdue delinquency reports and fine collection tracking.</a:t>
+                  <a:srgbClr val="A1A1AA"/>
+                </a:solidFill>
+              </a:defRPr>
+            </a:pPr>
+            <a:r>
+              <a:t>• Circulation Analytics: Overdue delinquency reports and fine collection tracking ($1/day).</a:t>
             </a:r>
           </a:p>
           <a:p>
@@ -8270,12 +7221,12 @@
               </a:spcAft>
               <a:defRPr sz="1100">
                 <a:solidFill>
-                  <a:srgbClr val="64748B"/>
-                </a:solidFill>
-              </a:defRPr>
-            </a:pPr>
-            <a:r>
-              <a:t>• Security Oversight: Role-based authorization rules and user credential auditing.</a:t>
+                  <a:srgbClr val="A1A1AA"/>
+                </a:solidFill>
+              </a:defRPr>
+            </a:pPr>
+            <a:r>
+              <a:t>• Security Oversight: Role-based authorization rules and password hash verification.</a:t>
             </a:r>
           </a:p>
           <a:p>
@@ -8285,12 +7236,12 @@
               </a:spcAft>
               <a:defRPr sz="1100">
                 <a:solidFill>
-                  <a:srgbClr val="64748B"/>
-                </a:solidFill>
-              </a:defRPr>
-            </a:pPr>
-            <a:r>
-              <a:t>• Audit Ledger: Complete historical trail of all checkout, return, and fine events.</a:t>
+                  <a:srgbClr val="A1A1AA"/>
+                </a:solidFill>
+              </a:defRPr>
+            </a:pPr>
+            <a:r>
+              <a:t>• Audit Ledger: Complete historical trail of all checkout, return, extension, and fine events.</a:t>
             </a:r>
           </a:p>
         </p:txBody>
@@ -8306,6 +7257,14 @@
 <file path=ppt/slides/slide9.xml><?xml version="1.0" encoding="utf-8"?>
 <p:sld xmlns:a="http://schemas.openxmlformats.org/drawingml/2006/main" xmlns:p="http://schemas.openxmlformats.org/presentationml/2006/main" xmlns:r="http://schemas.openxmlformats.org/officeDocument/2006/relationships">
   <p:cSld>
+    <p:bg>
+      <p:bgPr>
+        <a:solidFill>
+          <a:srgbClr val="09090B"/>
+        </a:solidFill>
+        <a:effectLst/>
+      </p:bgPr>
+    </p:bg>
     <p:spTree>
       <p:nvGrpSpPr>
         <p:cNvPr id="1" name=""/>
@@ -8315,44 +7274,36 @@
       <p:grpSpPr/>
       <p:sp>
         <p:nvSpPr>
-          <p:cNvPr id="2" name="Rectangle 1"/>
-          <p:cNvSpPr/>
+          <p:cNvPr id="2" name="TextBox 1"/>
+          <p:cNvSpPr txBox="1"/>
           <p:nvPr/>
         </p:nvSpPr>
         <p:spPr>
           <a:xfrm>
-            <a:off x="0" y="0"/>
-            <a:ext cx="12191695" cy="6858000"/>
+            <a:off x="731520" y="502920"/>
+            <a:ext cx="10698480" cy="365760"/>
           </a:xfrm>
           <a:prstGeom prst="rect">
             <a:avLst/>
           </a:prstGeom>
-          <a:solidFill>
-            <a:srgbClr val="F8FAFC"/>
-          </a:solidFill>
-          <a:ln>
-            <a:noFill/>
-          </a:ln>
-        </p:spPr>
-        <p:style>
-          <a:lnRef idx="1">
-            <a:schemeClr val="accent1"/>
-          </a:lnRef>
-          <a:fillRef idx="3">
-            <a:schemeClr val="accent1"/>
-          </a:fillRef>
-          <a:effectRef idx="2">
-            <a:schemeClr val="accent1"/>
-          </a:effectRef>
-          <a:fontRef idx="minor">
-            <a:schemeClr val="lt1"/>
-          </a:fontRef>
-        </p:style>
-        <p:txBody>
-          <a:bodyPr rtlCol="0" anchor="ctr"/>
-          <a:lstStyle/>
-          <a:p>
-            <a:pPr algn="ctr"/>
+          <a:noFill/>
+        </p:spPr>
+        <p:txBody>
+          <a:bodyPr wrap="square">
+            <a:spAutoFit/>
+          </a:bodyPr>
+          <a:lstStyle/>
+          <a:p>
+            <a:pPr>
+              <a:defRPr sz="1100" b="1">
+                <a:solidFill>
+                  <a:srgbClr val="0071E3"/>
+                </a:solidFill>
+              </a:defRPr>
+            </a:pPr>
+            <a:r>
+              <a:t>DIGITAL EXTENSION • OPEN SOURCE INTEGRATION</a:t>
+            </a:r>
           </a:p>
         </p:txBody>
       </p:sp>
@@ -8364,8 +7315,8 @@
         </p:nvSpPr>
         <p:spPr>
           <a:xfrm>
-            <a:off x="731520" y="457200"/>
-            <a:ext cx="10698480" cy="1005840"/>
+            <a:off x="731520" y="777240"/>
+            <a:ext cx="10698480" cy="731520"/>
           </a:xfrm>
           <a:prstGeom prst="rect">
             <a:avLst/>
@@ -8379,24 +7330,9 @@
           <a:lstStyle/>
           <a:p>
             <a:pPr>
-              <a:spcAft>
-                <a:spcPts val="400"/>
-              </a:spcAft>
-              <a:defRPr sz="1100" b="1">
-                <a:solidFill>
-                  <a:srgbClr val="0071E3"/>
-                </a:solidFill>
-              </a:defRPr>
-            </a:pPr>
-            <a:r>
-              <a:t>DIGITAL EXTENSION • OPEN SOURCE INTEGRATION</a:t>
-            </a:r>
-          </a:p>
-          <a:p>
-            <a:pPr>
-              <a:defRPr sz="2500" b="1">
-                <a:solidFill>
-                  <a:srgbClr val="0F172A"/>
+              <a:defRPr sz="2600" b="1">
+                <a:solidFill>
+                  <a:srgbClr val="FAFAFA"/>
                 </a:solidFill>
               </a:defRPr>
             </a:pPr>
@@ -8421,11 +7357,11 @@
             <a:avLst/>
           </a:prstGeom>
           <a:solidFill>
-            <a:srgbClr val="FFFFFF"/>
+            <a:srgbClr val="141418"/>
           </a:solidFill>
-          <a:ln w="12700">
+          <a:ln w="15240">
             <a:solidFill>
-              <a:srgbClr val="E2E8F0"/>
+              <a:srgbClr val="27272E"/>
             </a:solidFill>
           </a:ln>
         </p:spPr>
@@ -8522,12 +7458,12 @@
               </a:spcAft>
               <a:defRPr sz="1700" b="1">
                 <a:solidFill>
-                  <a:srgbClr val="0F172A"/>
-                </a:solidFill>
-              </a:defRPr>
-            </a:pPr>
-            <a:r>
-              <a:t>Internet Archive &amp; Open Library Integration</a:t>
+                  <a:srgbClr val="FAFAFA"/>
+                </a:solidFill>
+              </a:defRPr>
+            </a:pPr>
+            <a:r>
+              <a:t>Open Library &amp; Internet Archive Integration</a:t>
             </a:r>
           </a:p>
           <a:p>
@@ -8537,12 +7473,12 @@
               </a:spcAft>
               <a:defRPr sz="1200">
                 <a:solidFill>
-                  <a:srgbClr val="64748B"/>
-                </a:solidFill>
-              </a:defRPr>
-            </a:pPr>
-            <a:r>
-              <a:t>• Live Open-Search Proxy: Queries Open Library API with full-text filter across millions of free works.</a:t>
+                  <a:srgbClr val="A1A1AA"/>
+                </a:solidFill>
+              </a:defRPr>
+            </a:pPr>
+            <a:r>
+              <a:t>• Public Domain Search: Proxied GET /api/books/open-search queries Open Library's Search API for full-text items.</a:t>
             </a:r>
           </a:p>
           <a:p>
@@ -8552,12 +7488,12 @@
               </a:spcAft>
               <a:defRPr sz="1200">
                 <a:solidFill>
-                  <a:srgbClr val="64748B"/>
-                </a:solidFill>
-              </a:defRPr>
-            </a:pPr>
-            <a:r>
-              <a:t>• Quick Topic Exploration: One-click preset filters for Operating Systems, Relational Databases, AI, and Algorithms.</a:t>
+                  <a:srgbClr val="A1A1AA"/>
+                </a:solidFill>
+              </a:defRPr>
+            </a:pPr>
+            <a:r>
+              <a:t>• Direct IA Resolution: Maps Internet Archive identifiers to direct embed streams (https://archive.org/embed/{ia_id}).</a:t>
             </a:r>
           </a:p>
           <a:p>
@@ -8567,12 +7503,12 @@
               </a:spcAft>
               <a:defRPr sz="1200">
                 <a:solidFill>
-                  <a:srgbClr val="64748B"/>
-                </a:solidFill>
-              </a:defRPr>
-            </a:pPr>
-            <a:r>
-              <a:t>• Automatic Catalog Bridge: When local stacks have 0 copies, automatically prompts to search in the Open E-Library.</a:t>
+                  <a:srgbClr val="A1A1AA"/>
+                </a:solidFill>
+              </a:defRPr>
+            </a:pPr>
+            <a:r>
+              <a:t>• Auto-Cataloging: Scanned ISBNs auto-resolve metadata (publishers, edition year, authors, cover images).</a:t>
             </a:r>
           </a:p>
           <a:p>
@@ -8582,12 +7518,12 @@
               </a:spcAft>
               <a:defRPr sz="1200">
                 <a:solidFill>
-                  <a:srgbClr val="64748B"/>
-                </a:solidFill>
-              </a:defRPr>
-            </a:pPr>
-            <a:r>
-              <a:t>• Direct PDF Downloads: Provides verified direct links to public domain digital volumes.</a:t>
+                  <a:srgbClr val="A1A1AA"/>
+                </a:solidFill>
+              </a:defRPr>
+            </a:pPr>
+            <a:r>
+              <a:t>• Curated Classics: Includes full editions of SICP, Turing (1936), Algorithms, and Computer Organization.</a:t>
             </a:r>
           </a:p>
         </p:txBody>
@@ -8607,11 +7543,11 @@
             <a:avLst/>
           </a:prstGeom>
           <a:solidFill>
-            <a:srgbClr val="FFFFFF"/>
+            <a:srgbClr val="141418"/>
           </a:solidFill>
-          <a:ln w="12700">
+          <a:ln w="15240">
             <a:solidFill>
-              <a:srgbClr val="E2E8F0"/>
+              <a:srgbClr val="27272E"/>
             </a:solidFill>
           </a:ln>
         </p:spPr>
@@ -8652,7 +7588,7 @@
             <a:avLst/>
           </a:prstGeom>
           <a:solidFill>
-            <a:srgbClr val="4F46E5"/>
+            <a:srgbClr val="8B5CF6"/>
           </a:solidFill>
           <a:ln>
             <a:noFill/>
@@ -8708,12 +7644,12 @@
               </a:spcAft>
               <a:defRPr sz="1700" b="1">
                 <a:solidFill>
-                  <a:srgbClr val="0F172A"/>
-                </a:solidFill>
-              </a:defRPr>
-            </a:pPr>
-            <a:r>
-              <a:t>High-Performance Interactive E-Reader</a:t>
+                  <a:srgbClr val="FAFAFA"/>
+                </a:solidFill>
+              </a:defRPr>
+            </a:pPr>
+            <a:r>
+              <a:t>Custom Embedded Reader Experience</a:t>
             </a:r>
           </a:p>
           <a:p>
@@ -8723,12 +7659,12 @@
               </a:spcAft>
               <a:defRPr sz="1200">
                 <a:solidFill>
-                  <a:srgbClr val="64748B"/>
-                </a:solidFill>
-              </a:defRPr>
-            </a:pPr>
-            <a:r>
-              <a:t>• Fast-Embed Optimization: Embeds clean viewer with ?ui=embed, stripping redundant web wrapper overhead.</a:t>
+                  <a:srgbClr val="A1A1AA"/>
+                </a:solidFill>
+              </a:defRPr>
+            </a:pPr>
+            <a:r>
+              <a:t>• Maximized Reading Viewport: Expanded 86vh iframe height and max-w-[1550px] layout.</a:t>
             </a:r>
           </a:p>
           <a:p>
@@ -8738,12 +7674,12 @@
               </a:spcAft>
               <a:defRPr sz="1200">
                 <a:solidFill>
-                  <a:srgbClr val="64748B"/>
-                </a:solidFill>
-              </a:defRPr>
-            </a:pPr>
-            <a:r>
-              <a:t>• Widescreen Viewing (86vh): Dynamically expands layout to 1550px max width for reading 2-page spreads at a glance.</a:t>
+                  <a:srgbClr val="A1A1AA"/>
+                </a:solidFill>
+              </a:defRPr>
+            </a:pPr>
+            <a:r>
+              <a:t>• Embed URL Parameter: Appending ?ui=embed removes redundant headers for a fast, clean book spread.</a:t>
             </a:r>
           </a:p>
           <a:p>
@@ -8753,12 +7689,12 @@
               </a:spcAft>
               <a:defRPr sz="1200">
                 <a:solidFill>
-                  <a:srgbClr val="64748B"/>
-                </a:solidFill>
-              </a:defRPr>
-            </a:pPr>
-            <a:r>
-              <a:t>• Theater / Fullscreen Mode: One-click toggle expands the book reader to 100% viewport dimensions.</a:t>
+                  <a:srgbClr val="A1A1AA"/>
+                </a:solidFill>
+              </a:defRPr>
+            </a:pPr>
+            <a:r>
+              <a:t>• Multi-Modal Formats: Direct toggle between interactive 2-page e-reader canvas and downloadable PDF edition.</a:t>
             </a:r>
           </a:p>
           <a:p>
@@ -8768,12 +7704,12 @@
               </a:spcAft>
               <a:defRPr sz="1200">
                 <a:solidFill>
-                  <a:srgbClr val="64748B"/>
-                </a:solidFill>
-              </a:defRPr>
-            </a:pPr>
-            <a:r>
-              <a:t>• Fallback Streaming: Dual reader tabs support interactive 2-page flipbook mode and fullscreen PDF mode.</a:t>
+                  <a:srgbClr val="A1A1AA"/>
+                </a:solidFill>
+              </a:defRPr>
+            </a:pPr>
+            <a:r>
+              <a:t>• Zero Auth Wall: Free open-access books accessible to guest visitors without mandatory login.</a:t>
             </a:r>
           </a:p>
         </p:txBody>

</xml_diff>